<commit_message>
fix: GPL-3.0 e slides/API em linguagem de sala
<p>Troca MIT por GPL-3.0; redefine slides em torno de objetivo, entrada, saída e pareamento fluxo↔código; renomeia produto_na_pagina e reescreve os cálculos com nomes de produtos.</p>

Co-authored-by: Cursor <cursoragent@cursor.com>
</commit_message>
<xml_diff>
--- a/slides/recomendador-bentoml.pptx
+++ b/slides/recomendador-bentoml.pptx
@@ -3143,8 +3143,8 @@
         </p:nvSpPr>
         <p:spPr>
           <a:xfrm>
-            <a:off x="822960" y="1280160"/>
-            <a:ext cx="10515600" cy="914400"/>
+            <a:off x="731520" y="502920"/>
+            <a:ext cx="10698480" cy="640080"/>
           </a:xfrm>
           <a:prstGeom prst="rect">
             <a:avLst/>
@@ -3163,13 +3163,13 @@
               </a:spcAft>
             </a:pPr>
             <a:r>
-              <a:rPr sz="4000" b="1" i="0">
+              <a:rPr sz="3600" b="1">
                 <a:solidFill>
                   <a:srgbClr val="FFFFFF"/>
                 </a:solidFill>
                 <a:latin typeface="Georgia"/>
               </a:rPr>
-              <a:t>Recomendação como serviço</a:t>
+              <a:t>Objetivo desta aula</a:t>
             </a:r>
           </a:p>
         </p:txBody>
@@ -3182,8 +3182,8 @@
         </p:nvSpPr>
         <p:spPr>
           <a:xfrm>
-            <a:off x="822960" y="2286000"/>
-            <a:ext cx="10515600" cy="3474720"/>
+            <a:off x="731520" y="1325880"/>
+            <a:ext cx="10698480" cy="1097280"/>
           </a:xfrm>
           <a:prstGeom prst="rect">
             <a:avLst/>
@@ -3198,143 +3198,341 @@
           <a:p>
             <a:pPr algn="l">
               <a:spcAft>
-                <a:spcPts val="600"/>
+                <a:spcPts val="400"/>
               </a:spcAft>
             </a:pPr>
             <a:r>
-              <a:rPr sz="2200" b="0" i="0">
+              <a:rPr sz="2200" b="0">
                 <a:solidFill>
                   <a:srgbClr val="D5E0DE"/>
                 </a:solidFill>
                 <a:latin typeface="Calibri"/>
               </a:rPr>
-              <a:t>Hoje subimos um baseline honesto: mesma técnica do produto âncora,</a:t>
+              <a:t>Fazer o computador sugerir outros produtos quando o cliente</a:t>
             </a:r>
           </a:p>
           <a:p>
             <a:pPr algn="l">
               <a:spcAft>
-                <a:spcPts val="600"/>
+                <a:spcPts val="400"/>
               </a:spcAft>
             </a:pPr>
             <a:r>
-              <a:rPr sz="2200" b="0" i="0">
+              <a:rPr sz="2200" b="0">
                 <a:solidFill>
                   <a:srgbClr val="D5E0DE"/>
                 </a:solidFill>
                 <a:latin typeface="Calibri"/>
               </a:rPr>
-              <a:t>ordenado por popularidade, com fallback pelos mais pedidos.</a:t>
-            </a:r>
-          </a:p>
+              <a:t>abre a página de um produto — e publicar isso como serviço HTTP.</a:t>
+            </a:r>
+          </a:p>
+        </p:txBody>
+      </p:sp>
+      <p:sp>
+        <p:nvSpPr>
+          <p:cNvPr id="5" name="Rounded Rectangle 4"/>
+          <p:cNvSpPr/>
+          <p:nvPr/>
+        </p:nvSpPr>
+        <p:spPr>
+          <a:xfrm>
+            <a:off x="731520" y="2743200"/>
+            <a:ext cx="5029200" cy="2560320"/>
+          </a:xfrm>
+          <a:prstGeom prst="roundRect">
+            <a:avLst/>
+          </a:prstGeom>
+          <a:solidFill>
+            <a:srgbClr val="243236"/>
+          </a:solidFill>
+          <a:ln>
+            <a:noFill/>
+          </a:ln>
+          <a:effectLst/>
+        </p:spPr>
+        <p:style>
+          <a:lnRef idx="1">
+            <a:schemeClr val="accent1"/>
+          </a:lnRef>
+          <a:fillRef idx="3">
+            <a:schemeClr val="accent1"/>
+          </a:fillRef>
+          <a:effectRef idx="2">
+            <a:schemeClr val="accent1"/>
+          </a:effectRef>
+          <a:fontRef idx="minor">
+            <a:schemeClr val="lt1"/>
+          </a:fontRef>
+        </p:style>
+        <p:txBody>
+          <a:bodyPr rtlCol="0" anchor="ctr"/>
+          <a:lstStyle/>
+          <a:p>
+            <a:pPr algn="ctr"/>
+          </a:p>
+        </p:txBody>
+      </p:sp>
+      <p:sp>
+        <p:nvSpPr>
+          <p:cNvPr id="6" name="TextBox 5"/>
+          <p:cNvSpPr txBox="1"/>
+          <p:nvPr/>
+        </p:nvSpPr>
+        <p:spPr>
+          <a:xfrm>
+            <a:off x="914400" y="2880360"/>
+            <a:ext cx="4663440" cy="2286000"/>
+          </a:xfrm>
+          <a:prstGeom prst="rect">
+            <a:avLst/>
+          </a:prstGeom>
+          <a:noFill/>
+        </p:spPr>
+        <p:txBody>
+          <a:bodyPr wrap="square" lIns="50800" rIns="50800" tIns="25400" bIns="25400">
+            <a:spAutoFit/>
+          </a:bodyPr>
+          <a:lstStyle/>
           <a:p>
             <a:pPr algn="l">
               <a:spcAft>
-                <a:spcPts val="600"/>
+                <a:spcPts val="400"/>
               </a:spcAft>
             </a:pPr>
             <a:r>
-              <a:rPr sz="2200" b="0" i="0">
-                <a:solidFill>
-                  <a:srgbClr val="D5E0DE"/>
+              <a:rPr sz="1800" b="0">
+                <a:solidFill>
+                  <a:srgbClr val="FFFFFF"/>
                 </a:solidFill>
                 <a:latin typeface="Calibri"/>
               </a:rPr>
-              <a:t/>
+              <a:t>ENTRADA</a:t>
             </a:r>
           </a:p>
           <a:p>
             <a:pPr algn="l">
               <a:spcAft>
-                <a:spcPts val="600"/>
+                <a:spcPts val="400"/>
               </a:spcAft>
             </a:pPr>
             <a:r>
-              <a:rPr sz="2200" b="0" i="0">
-                <a:solidFill>
-                  <a:srgbClr val="D5E0DE"/>
+              <a:rPr sz="1800" b="0">
+                <a:solidFill>
+                  <a:srgbClr val="FFFFFF"/>
                 </a:solidFill>
                 <a:latin typeface="Calibri"/>
               </a:rPr>
-              <a:t>Não é filtragem colaborativa. Não há histórico real de navegação.</a:t>
+              <a:t/>
             </a:r>
           </a:p>
           <a:p>
             <a:pPr algn="l">
               <a:spcAft>
-                <a:spcPts val="600"/>
+                <a:spcPts val="400"/>
               </a:spcAft>
             </a:pPr>
             <a:r>
-              <a:rPr sz="2200" b="0" i="0">
-                <a:solidFill>
-                  <a:srgbClr val="D5E0DE"/>
+              <a:rPr sz="1800" b="0">
+                <a:solidFill>
+                  <a:srgbClr val="FFFFFF"/>
                 </a:solidFill>
                 <a:latin typeface="Calibri"/>
               </a:rPr>
-              <a:t>O contrato HTTP (BentoML) é o que a vitrine vai consumir depois.</a:t>
+              <a:t>• produto_na_pagina  (ex.: p01)</a:t>
             </a:r>
           </a:p>
           <a:p>
             <a:pPr algn="l">
               <a:spcAft>
-                <a:spcPts val="600"/>
+                <a:spcPts val="400"/>
               </a:spcAft>
             </a:pPr>
             <a:r>
-              <a:rPr sz="2200" b="0" i="0">
-                <a:solidFill>
-                  <a:srgbClr val="D5E0DE"/>
+              <a:rPr sz="1800" b="0">
+                <a:solidFill>
+                  <a:srgbClr val="FFFFFF"/>
                 </a:solidFill>
                 <a:latin typeface="Calibri"/>
               </a:rPr>
-              <a:t/>
+              <a:t>• limite  (ex.: 4)</a:t>
             </a:r>
           </a:p>
           <a:p>
             <a:pPr algn="l">
               <a:spcAft>
-                <a:spcPts val="600"/>
+                <a:spcPts val="400"/>
               </a:spcAft>
             </a:pPr>
             <a:r>
-              <a:rPr sz="2200" b="0" i="0">
-                <a:solidFill>
-                  <a:srgbClr val="D5E0DE"/>
+              <a:rPr sz="1800" b="0">
+                <a:solidFill>
+                  <a:srgbClr val="FFFFFF"/>
                 </a:solidFill>
                 <a:latin typeface="Calibri"/>
               </a:rPr>
-              <a:t>Objetivo da aula: treinar o artefato, servir em localhost:3000,</a:t>
-            </a:r>
-          </a:p>
+              <a:t>• excluir  (lista de ids)</a:t>
+            </a:r>
+          </a:p>
+        </p:txBody>
+      </p:sp>
+      <p:sp>
+        <p:nvSpPr>
+          <p:cNvPr id="7" name="Rounded Rectangle 6"/>
+          <p:cNvSpPr/>
+          <p:nvPr/>
+        </p:nvSpPr>
+        <p:spPr>
+          <a:xfrm>
+            <a:off x="6309360" y="2743200"/>
+            <a:ext cx="5029200" cy="2560320"/>
+          </a:xfrm>
+          <a:prstGeom prst="roundRect">
+            <a:avLst/>
+          </a:prstGeom>
+          <a:solidFill>
+            <a:srgbClr val="0D7A6F"/>
+          </a:solidFill>
+          <a:ln>
+            <a:noFill/>
+          </a:ln>
+          <a:effectLst/>
+        </p:spPr>
+        <p:style>
+          <a:lnRef idx="1">
+            <a:schemeClr val="accent1"/>
+          </a:lnRef>
+          <a:fillRef idx="3">
+            <a:schemeClr val="accent1"/>
+          </a:fillRef>
+          <a:effectRef idx="2">
+            <a:schemeClr val="accent1"/>
+          </a:effectRef>
+          <a:fontRef idx="minor">
+            <a:schemeClr val="lt1"/>
+          </a:fontRef>
+        </p:style>
+        <p:txBody>
+          <a:bodyPr rtlCol="0" anchor="ctr"/>
+          <a:lstStyle/>
+          <a:p>
+            <a:pPr algn="ctr"/>
+          </a:p>
+        </p:txBody>
+      </p:sp>
+      <p:sp>
+        <p:nvSpPr>
+          <p:cNvPr id="8" name="TextBox 7"/>
+          <p:cNvSpPr txBox="1"/>
+          <p:nvPr/>
+        </p:nvSpPr>
+        <p:spPr>
+          <a:xfrm>
+            <a:off x="6492240" y="2880360"/>
+            <a:ext cx="4663440" cy="2286000"/>
+          </a:xfrm>
+          <a:prstGeom prst="rect">
+            <a:avLst/>
+          </a:prstGeom>
+          <a:noFill/>
+        </p:spPr>
+        <p:txBody>
+          <a:bodyPr wrap="square" lIns="50800" rIns="50800" tIns="25400" bIns="25400">
+            <a:spAutoFit/>
+          </a:bodyPr>
+          <a:lstStyle/>
           <a:p>
             <a:pPr algn="l">
               <a:spcAft>
-                <a:spcPts val="600"/>
+                <a:spcPts val="400"/>
               </a:spcAft>
             </a:pPr>
             <a:r>
-              <a:rPr sz="2200" b="0" i="0">
-                <a:solidFill>
-                  <a:srgbClr val="D5E0DE"/>
+              <a:rPr sz="1800" b="0">
+                <a:solidFill>
+                  <a:srgbClr val="FFFFFF"/>
                 </a:solidFill>
                 <a:latin typeface="Calibri"/>
               </a:rPr>
-              <a:t>ler o JSON e saber repetir as contas do score no papel.</a:t>
-            </a:r>
-          </a:p>
-        </p:txBody>
-      </p:sp>
-      <p:sp>
-        <p:nvSpPr>
-          <p:cNvPr id="5" name="TextBox 4"/>
+              <a:t>SAÍDA</a:t>
+            </a:r>
+          </a:p>
+          <a:p>
+            <a:pPr algn="l">
+              <a:spcAft>
+                <a:spcPts val="400"/>
+              </a:spcAft>
+            </a:pPr>
+            <a:r>
+              <a:rPr sz="1800" b="0">
+                <a:solidFill>
+                  <a:srgbClr val="FFFFFF"/>
+                </a:solidFill>
+                <a:latin typeface="Calibri"/>
+              </a:rPr>
+              <a:t/>
+            </a:r>
+          </a:p>
+          <a:p>
+            <a:pPr algn="l">
+              <a:spcAft>
+                <a:spcPts val="400"/>
+              </a:spcAft>
+            </a:pPr>
+            <a:r>
+              <a:rPr sz="1800" b="0">
+                <a:solidFill>
+                  <a:srgbClr val="FFFFFF"/>
+                </a:solidFill>
+                <a:latin typeface="Calibri"/>
+              </a:rPr>
+              <a:t>• lista de produtos</a:t>
+            </a:r>
+          </a:p>
+          <a:p>
+            <a:pPr algn="l">
+              <a:spcAft>
+                <a:spcPts val="400"/>
+              </a:spcAft>
+            </a:pPr>
+            <a:r>
+              <a:rPr sz="1800" b="0">
+                <a:solidFill>
+                  <a:srgbClr val="FFFFFF"/>
+                </a:solidFill>
+                <a:latin typeface="Calibri"/>
+              </a:rPr>
+              <a:t>• cada um com nome, nota</a:t>
+            </a:r>
+          </a:p>
+          <a:p>
+            <a:pPr algn="l">
+              <a:spcAft>
+                <a:spcPts val="400"/>
+              </a:spcAft>
+            </a:pPr>
+            <a:r>
+              <a:rPr sz="1800" b="0">
+                <a:solidFill>
+                  <a:srgbClr val="FFFFFF"/>
+                </a:solidFill>
+                <a:latin typeface="Calibri"/>
+              </a:rPr>
+              <a:t>  e posição na lista</a:t>
+            </a:r>
+          </a:p>
+        </p:txBody>
+      </p:sp>
+      <p:sp>
+        <p:nvSpPr>
+          <p:cNvPr id="9" name="TextBox 8"/>
           <p:cNvSpPr txBox="1"/>
           <p:nvPr/>
         </p:nvSpPr>
         <p:spPr>
           <a:xfrm>
-            <a:off x="822960" y="6126480"/>
-            <a:ext cx="10515600" cy="365760"/>
+            <a:off x="731520" y="6126480"/>
+            <a:ext cx="10972800" cy="320040"/>
           </a:xfrm>
           <a:prstGeom prst="rect">
             <a:avLst/>
@@ -3353,13 +3551,13 @@
               </a:spcAft>
             </a:pPr>
             <a:r>
-              <a:rPr sz="1200" b="0" i="0">
+              <a:rPr sz="1200" b="0">
                 <a:solidFill>
                   <a:srgbClr val="4A5558"/>
                 </a:solidFill>
                 <a:latin typeface="Calibri"/>
               </a:rPr>
-              <a:t>1 / 5  ·  texto</a:t>
+              <a:t>1 / 5</a:t>
             </a:r>
           </a:p>
         </p:txBody>
@@ -3433,8 +3631,8 @@
         </p:nvSpPr>
         <p:spPr>
           <a:xfrm>
-            <a:off x="640080" y="320040"/>
-            <a:ext cx="10972800" cy="548640"/>
+            <a:off x="548640" y="274320"/>
+            <a:ext cx="10972800" cy="502920"/>
           </a:xfrm>
           <a:prstGeom prst="rect">
             <a:avLst/>
@@ -3453,52 +3651,78 @@
               </a:spcAft>
             </a:pPr>
             <a:r>
-              <a:rPr sz="3200" b="1" i="0">
+              <a:rPr sz="3000" b="1">
                 <a:solidFill>
                   <a:srgbClr val="1A1A1A"/>
                 </a:solidFill>
                 <a:latin typeface="Georgia"/>
               </a:rPr>
-              <a:t>Do catálogo ao HTTP</a:t>
-            </a:r>
-          </a:p>
-        </p:txBody>
-      </p:sp>
-      <p:sp>
-        <p:nvSpPr>
-          <p:cNvPr id="4" name="TextBox 3"/>
-          <p:cNvSpPr txBox="1"/>
+              <a:t>Fluxo e onde está no código</a:t>
+            </a:r>
+          </a:p>
+        </p:txBody>
+      </p:sp>
+      <p:sp>
+        <p:nvSpPr>
+          <p:cNvPr id="4" name="Rounded Rectangle 3"/>
+          <p:cNvSpPr/>
           <p:nvPr/>
         </p:nvSpPr>
         <p:spPr>
           <a:xfrm>
-            <a:off x="640080" y="868680"/>
-            <a:ext cx="10972800" cy="365760"/>
-          </a:xfrm>
-          <a:prstGeom prst="rect">
+            <a:off x="411480" y="1371600"/>
+            <a:ext cx="1965960" cy="1325880"/>
+          </a:xfrm>
+          <a:prstGeom prst="roundRect">
             <a:avLst/>
           </a:prstGeom>
-          <a:noFill/>
-        </p:spPr>
-        <p:txBody>
-          <a:bodyPr wrap="square" lIns="50800" rIns="50800" tIns="25400" bIns="25400">
-            <a:spAutoFit/>
-          </a:bodyPr>
-          <a:lstStyle/>
-          <a:p>
-            <a:pPr algn="l">
-              <a:spcAft>
-                <a:spcPts val="800"/>
-              </a:spcAft>
-            </a:pPr>
-            <a:r>
-              <a:rPr sz="1600" b="0" i="0">
-                <a:solidFill>
-                  <a:srgbClr val="4A5558"/>
+          <a:solidFill>
+            <a:srgbClr val="0D7A6F"/>
+          </a:solidFill>
+          <a:ln>
+            <a:noFill/>
+          </a:ln>
+          <a:effectLst/>
+        </p:spPr>
+        <p:style>
+          <a:lnRef idx="1">
+            <a:schemeClr val="accent1"/>
+          </a:lnRef>
+          <a:fillRef idx="3">
+            <a:schemeClr val="accent1"/>
+          </a:fillRef>
+          <a:effectRef idx="2">
+            <a:schemeClr val="accent1"/>
+          </a:effectRef>
+          <a:fontRef idx="minor">
+            <a:schemeClr val="lt1"/>
+          </a:fontRef>
+        </p:style>
+        <p:txBody>
+          <a:bodyPr rtlCol="0" anchor="ctr"/>
+          <a:lstStyle/>
+          <a:p>
+            <a:pPr algn="ctr"/>
+            <a:r>
+              <a:rPr sz="1300" b="1">
+                <a:solidFill>
+                  <a:srgbClr val="FFFFFF"/>
                 </a:solidFill>
                 <a:latin typeface="Calibri"/>
               </a:rPr>
-              <a:t>Fluxo desta pasta — nada de outro repositório</a:t>
+              <a:t>1. Ler catálogo</a:t>
+            </a:r>
+          </a:p>
+          <a:p>
+            <a:pPr algn="ctr"/>
+            <a:r>
+              <a:rPr sz="1300" b="1">
+                <a:solidFill>
+                  <a:srgbClr val="FFFFFF"/>
+                </a:solidFill>
+                <a:latin typeface="Calibri"/>
+              </a:rPr>
+              <a:t>e cestas</a:t>
             </a:r>
           </a:p>
         </p:txBody>
@@ -3511,8 +3735,8 @@
         </p:nvSpPr>
         <p:spPr>
           <a:xfrm>
-            <a:off x="502920" y="2377440"/>
-            <a:ext cx="1828800" cy="1234440"/>
+            <a:off x="411480" y="3657600"/>
+            <a:ext cx="1965960" cy="1325880"/>
           </a:xfrm>
           <a:prstGeom prst="roundRect">
             <a:avLst/>
@@ -3520,8 +3744,10 @@
           <a:solidFill>
             <a:srgbClr val="E8F2F0"/>
           </a:solidFill>
-          <a:ln>
-            <a:noFill/>
+          <a:ln w="15875">
+            <a:solidFill>
+              <a:srgbClr val="0D7A6F"/>
+            </a:solidFill>
           </a:ln>
           <a:effectLst/>
         </p:spPr>
@@ -3540,16 +3766,16 @@
           </a:fontRef>
         </p:style>
         <p:txBody>
-          <a:bodyPr rtlCol="0" anchor="ctr" wrap="square"/>
+          <a:bodyPr rtlCol="0" anchor="ctr"/>
           <a:lstStyle/>
           <a:p>
             <a:pPr algn="ctr"/>
             <a:r>
-              <a:rPr sz="1400" b="1" i="0">
+              <a:rPr sz="1300" b="1">
                 <a:solidFill>
                   <a:srgbClr val="1A1A1A"/>
                 </a:solidFill>
-                <a:latin typeface="Calibri"/>
+                <a:latin typeface="Consolas"/>
               </a:rPr>
               <a:t>dados/</a:t>
             </a:r>
@@ -3557,11 +3783,11 @@
           <a:p>
             <a:pPr algn="ctr"/>
             <a:r>
-              <a:rPr sz="1400" b="1" i="0">
+              <a:rPr sz="1300" b="1">
                 <a:solidFill>
                   <a:srgbClr val="1A1A1A"/>
                 </a:solidFill>
-                <a:latin typeface="Calibri"/>
+                <a:latin typeface="Consolas"/>
               </a:rPr>
               <a:t>catalogo.json</a:t>
             </a:r>
@@ -3576,8 +3802,8 @@
         </p:nvSpPr>
         <p:spPr>
           <a:xfrm>
-            <a:off x="2331720" y="2974660"/>
-            <a:ext cx="210312" cy="40000"/>
+            <a:off x="1379460" y="2697480"/>
+            <a:ext cx="30000" cy="960120"/>
           </a:xfrm>
           <a:prstGeom prst="rect">
             <a:avLst/>
@@ -3614,13 +3840,57 @@
       </p:sp>
       <p:sp>
         <p:nvSpPr>
-          <p:cNvPr id="7" name="Right Arrow 6"/>
+          <p:cNvPr id="7" name="Rectangle 6"/>
           <p:cNvSpPr/>
           <p:nvPr/>
         </p:nvSpPr>
         <p:spPr>
           <a:xfrm>
-            <a:off x="2450592" y="2884932"/>
+            <a:off x="2377440" y="2014540"/>
+            <a:ext cx="146304" cy="40000"/>
+          </a:xfrm>
+          <a:prstGeom prst="rect">
+            <a:avLst/>
+          </a:prstGeom>
+          <a:solidFill>
+            <a:srgbClr val="0D7A6F"/>
+          </a:solidFill>
+          <a:ln>
+            <a:noFill/>
+          </a:ln>
+          <a:effectLst/>
+        </p:spPr>
+        <p:style>
+          <a:lnRef idx="1">
+            <a:schemeClr val="accent1"/>
+          </a:lnRef>
+          <a:fillRef idx="3">
+            <a:schemeClr val="accent1"/>
+          </a:fillRef>
+          <a:effectRef idx="2">
+            <a:schemeClr val="accent1"/>
+          </a:effectRef>
+          <a:fontRef idx="minor">
+            <a:schemeClr val="lt1"/>
+          </a:fontRef>
+        </p:style>
+        <p:txBody>
+          <a:bodyPr rtlCol="0" anchor="ctr"/>
+          <a:lstStyle/>
+          <a:p>
+            <a:pPr algn="ctr"/>
+          </a:p>
+        </p:txBody>
+      </p:sp>
+      <p:sp>
+        <p:nvSpPr>
+          <p:cNvPr id="8" name="Right Arrow 7"/>
+          <p:cNvSpPr/>
+          <p:nvPr/>
+        </p:nvSpPr>
+        <p:spPr>
+          <a:xfrm>
+            <a:off x="2432304" y="1924812"/>
             <a:ext cx="256032" cy="219456"/>
           </a:xfrm>
           <a:prstGeom prst="rightArrow">
@@ -3658,14 +3928,266 @@
       </p:sp>
       <p:sp>
         <p:nvSpPr>
-          <p:cNvPr id="8" name="Rounded Rectangle 7"/>
+          <p:cNvPr id="9" name="Rounded Rectangle 8"/>
           <p:cNvSpPr/>
           <p:nvPr/>
         </p:nvSpPr>
         <p:spPr>
           <a:xfrm>
-            <a:off x="2651760" y="2377440"/>
-            <a:ext cx="1828800" cy="1234440"/>
+            <a:off x="2633472" y="1371600"/>
+            <a:ext cx="1965960" cy="1325880"/>
+          </a:xfrm>
+          <a:prstGeom prst="roundRect">
+            <a:avLst/>
+          </a:prstGeom>
+          <a:solidFill>
+            <a:srgbClr val="1E2A2E"/>
+          </a:solidFill>
+          <a:ln>
+            <a:noFill/>
+          </a:ln>
+          <a:effectLst/>
+        </p:spPr>
+        <p:style>
+          <a:lnRef idx="1">
+            <a:schemeClr val="accent1"/>
+          </a:lnRef>
+          <a:fillRef idx="3">
+            <a:schemeClr val="accent1"/>
+          </a:fillRef>
+          <a:effectRef idx="2">
+            <a:schemeClr val="accent1"/>
+          </a:effectRef>
+          <a:fontRef idx="minor">
+            <a:schemeClr val="lt1"/>
+          </a:fontRef>
+        </p:style>
+        <p:txBody>
+          <a:bodyPr rtlCol="0" anchor="ctr"/>
+          <a:lstStyle/>
+          <a:p>
+            <a:pPr algn="ctr"/>
+            <a:r>
+              <a:rPr sz="1300" b="1">
+                <a:solidFill>
+                  <a:srgbClr val="FFFFFF"/>
+                </a:solidFill>
+                <a:latin typeface="Calibri"/>
+              </a:rPr>
+              <a:t>2. Calcular notas</a:t>
+            </a:r>
+          </a:p>
+          <a:p>
+            <a:pPr algn="ctr"/>
+            <a:r>
+              <a:rPr sz="1300" b="1">
+                <a:solidFill>
+                  <a:srgbClr val="FFFFFF"/>
+                </a:solidFill>
+                <a:latin typeface="Calibri"/>
+              </a:rPr>
+              <a:t>e gravar</a:t>
+            </a:r>
+          </a:p>
+        </p:txBody>
+      </p:sp>
+      <p:sp>
+        <p:nvSpPr>
+          <p:cNvPr id="10" name="Rounded Rectangle 9"/>
+          <p:cNvSpPr/>
+          <p:nvPr/>
+        </p:nvSpPr>
+        <p:spPr>
+          <a:xfrm>
+            <a:off x="2633472" y="3657600"/>
+            <a:ext cx="1965960" cy="1325880"/>
+          </a:xfrm>
+          <a:prstGeom prst="roundRect">
+            <a:avLst/>
+          </a:prstGeom>
+          <a:solidFill>
+            <a:srgbClr val="E8F2F0"/>
+          </a:solidFill>
+          <a:ln w="15875">
+            <a:solidFill>
+              <a:srgbClr val="0D7A6F"/>
+            </a:solidFill>
+          </a:ln>
+          <a:effectLst/>
+        </p:spPr>
+        <p:style>
+          <a:lnRef idx="1">
+            <a:schemeClr val="accent1"/>
+          </a:lnRef>
+          <a:fillRef idx="3">
+            <a:schemeClr val="accent1"/>
+          </a:fillRef>
+          <a:effectRef idx="2">
+            <a:schemeClr val="accent1"/>
+          </a:effectRef>
+          <a:fontRef idx="minor">
+            <a:schemeClr val="lt1"/>
+          </a:fontRef>
+        </p:style>
+        <p:txBody>
+          <a:bodyPr rtlCol="0" anchor="ctr"/>
+          <a:lstStyle/>
+          <a:p>
+            <a:pPr algn="ctr"/>
+            <a:r>
+              <a:rPr sz="1300" b="1">
+                <a:solidFill>
+                  <a:srgbClr val="1A1A1A"/>
+                </a:solidFill>
+                <a:latin typeface="Consolas"/>
+              </a:rPr>
+              <a:t>treino.py</a:t>
+            </a:r>
+          </a:p>
+        </p:txBody>
+      </p:sp>
+      <p:sp>
+        <p:nvSpPr>
+          <p:cNvPr id="11" name="Rectangle 10"/>
+          <p:cNvSpPr/>
+          <p:nvPr/>
+        </p:nvSpPr>
+        <p:spPr>
+          <a:xfrm>
+            <a:off x="3601452" y="2697480"/>
+            <a:ext cx="30000" cy="960120"/>
+          </a:xfrm>
+          <a:prstGeom prst="rect">
+            <a:avLst/>
+          </a:prstGeom>
+          <a:solidFill>
+            <a:srgbClr val="0D7A6F"/>
+          </a:solidFill>
+          <a:ln>
+            <a:noFill/>
+          </a:ln>
+          <a:effectLst/>
+        </p:spPr>
+        <p:style>
+          <a:lnRef idx="1">
+            <a:schemeClr val="accent1"/>
+          </a:lnRef>
+          <a:fillRef idx="3">
+            <a:schemeClr val="accent1"/>
+          </a:fillRef>
+          <a:effectRef idx="2">
+            <a:schemeClr val="accent1"/>
+          </a:effectRef>
+          <a:fontRef idx="minor">
+            <a:schemeClr val="lt1"/>
+          </a:fontRef>
+        </p:style>
+        <p:txBody>
+          <a:bodyPr rtlCol="0" anchor="ctr"/>
+          <a:lstStyle/>
+          <a:p>
+            <a:pPr algn="ctr"/>
+          </a:p>
+        </p:txBody>
+      </p:sp>
+      <p:sp>
+        <p:nvSpPr>
+          <p:cNvPr id="12" name="Rectangle 11"/>
+          <p:cNvSpPr/>
+          <p:nvPr/>
+        </p:nvSpPr>
+        <p:spPr>
+          <a:xfrm>
+            <a:off x="4599432" y="2014540"/>
+            <a:ext cx="146304" cy="40000"/>
+          </a:xfrm>
+          <a:prstGeom prst="rect">
+            <a:avLst/>
+          </a:prstGeom>
+          <a:solidFill>
+            <a:srgbClr val="0D7A6F"/>
+          </a:solidFill>
+          <a:ln>
+            <a:noFill/>
+          </a:ln>
+          <a:effectLst/>
+        </p:spPr>
+        <p:style>
+          <a:lnRef idx="1">
+            <a:schemeClr val="accent1"/>
+          </a:lnRef>
+          <a:fillRef idx="3">
+            <a:schemeClr val="accent1"/>
+          </a:fillRef>
+          <a:effectRef idx="2">
+            <a:schemeClr val="accent1"/>
+          </a:effectRef>
+          <a:fontRef idx="minor">
+            <a:schemeClr val="lt1"/>
+          </a:fontRef>
+        </p:style>
+        <p:txBody>
+          <a:bodyPr rtlCol="0" anchor="ctr"/>
+          <a:lstStyle/>
+          <a:p>
+            <a:pPr algn="ctr"/>
+          </a:p>
+        </p:txBody>
+      </p:sp>
+      <p:sp>
+        <p:nvSpPr>
+          <p:cNvPr id="13" name="Right Arrow 12"/>
+          <p:cNvSpPr/>
+          <p:nvPr/>
+        </p:nvSpPr>
+        <p:spPr>
+          <a:xfrm>
+            <a:off x="4654296" y="1924812"/>
+            <a:ext cx="256032" cy="219456"/>
+          </a:xfrm>
+          <a:prstGeom prst="rightArrow">
+            <a:avLst/>
+          </a:prstGeom>
+          <a:solidFill>
+            <a:srgbClr val="0D7A6F"/>
+          </a:solidFill>
+          <a:ln>
+            <a:noFill/>
+          </a:ln>
+          <a:effectLst/>
+        </p:spPr>
+        <p:style>
+          <a:lnRef idx="1">
+            <a:schemeClr val="accent1"/>
+          </a:lnRef>
+          <a:fillRef idx="3">
+            <a:schemeClr val="accent1"/>
+          </a:fillRef>
+          <a:effectRef idx="2">
+            <a:schemeClr val="accent1"/>
+          </a:effectRef>
+          <a:fontRef idx="minor">
+            <a:schemeClr val="lt1"/>
+          </a:fontRef>
+        </p:style>
+        <p:txBody>
+          <a:bodyPr rtlCol="0" anchor="ctr"/>
+          <a:lstStyle/>
+          <a:p>
+            <a:pPr algn="ctr"/>
+          </a:p>
+        </p:txBody>
+      </p:sp>
+      <p:sp>
+        <p:nvSpPr>
+          <p:cNvPr id="14" name="Rounded Rectangle 13"/>
+          <p:cNvSpPr/>
+          <p:nvPr/>
+        </p:nvSpPr>
+        <p:spPr>
+          <a:xfrm>
+            <a:off x="4855464" y="1371600"/>
+            <a:ext cx="1965960" cy="1325880"/>
           </a:xfrm>
           <a:prstGeom prst="roundRect">
             <a:avLst/>
@@ -3693,24 +4215,24 @@
           </a:fontRef>
         </p:style>
         <p:txBody>
-          <a:bodyPr rtlCol="0" anchor="ctr" wrap="square"/>
+          <a:bodyPr rtlCol="0" anchor="ctr"/>
           <a:lstStyle/>
           <a:p>
             <a:pPr algn="ctr"/>
             <a:r>
-              <a:rPr sz="1400" b="1" i="0">
+              <a:rPr sz="1300" b="1">
                 <a:solidFill>
                   <a:srgbClr val="FFFFFF"/>
                 </a:solidFill>
                 <a:latin typeface="Calibri"/>
               </a:rPr>
-              <a:t>treino.py</a:t>
+              <a:t>3. Guardar</a:t>
             </a:r>
           </a:p>
           <a:p>
             <a:pPr algn="ctr"/>
             <a:r>
-              <a:rPr sz="1400" b="1" i="0">
+              <a:rPr sz="1300" b="1">
                 <a:solidFill>
                   <a:srgbClr val="FFFFFF"/>
                 </a:solidFill>
@@ -3723,14 +4245,81 @@
       </p:sp>
       <p:sp>
         <p:nvSpPr>
-          <p:cNvPr id="9" name="Rectangle 8"/>
+          <p:cNvPr id="15" name="Rounded Rectangle 14"/>
           <p:cNvSpPr/>
           <p:nvPr/>
         </p:nvSpPr>
         <p:spPr>
           <a:xfrm>
-            <a:off x="4480560" y="2974660"/>
-            <a:ext cx="210312" cy="40000"/>
+            <a:off x="4855464" y="3657600"/>
+            <a:ext cx="1965960" cy="1325880"/>
+          </a:xfrm>
+          <a:prstGeom prst="roundRect">
+            <a:avLst/>
+          </a:prstGeom>
+          <a:solidFill>
+            <a:srgbClr val="E8F2F0"/>
+          </a:solidFill>
+          <a:ln w="15875">
+            <a:solidFill>
+              <a:srgbClr val="0D7A6F"/>
+            </a:solidFill>
+          </a:ln>
+          <a:effectLst/>
+        </p:spPr>
+        <p:style>
+          <a:lnRef idx="1">
+            <a:schemeClr val="accent1"/>
+          </a:lnRef>
+          <a:fillRef idx="3">
+            <a:schemeClr val="accent1"/>
+          </a:fillRef>
+          <a:effectRef idx="2">
+            <a:schemeClr val="accent1"/>
+          </a:effectRef>
+          <a:fontRef idx="minor">
+            <a:schemeClr val="lt1"/>
+          </a:fontRef>
+        </p:style>
+        <p:txBody>
+          <a:bodyPr rtlCol="0" anchor="ctr"/>
+          <a:lstStyle/>
+          <a:p>
+            <a:pPr algn="ctr"/>
+            <a:r>
+              <a:rPr sz="1300" b="1">
+                <a:solidFill>
+                  <a:srgbClr val="1A1A1A"/>
+                </a:solidFill>
+                <a:latin typeface="Consolas"/>
+              </a:rPr>
+              <a:t>model store</a:t>
+            </a:r>
+          </a:p>
+          <a:p>
+            <a:pPr algn="ctr"/>
+            <a:r>
+              <a:rPr sz="1300" b="1">
+                <a:solidFill>
+                  <a:srgbClr val="1A1A1A"/>
+                </a:solidFill>
+                <a:latin typeface="Consolas"/>
+              </a:rPr>
+              <a:t>BentoML</a:t>
+            </a:r>
+          </a:p>
+        </p:txBody>
+      </p:sp>
+      <p:sp>
+        <p:nvSpPr>
+          <p:cNvPr id="16" name="Rectangle 15"/>
+          <p:cNvSpPr/>
+          <p:nvPr/>
+        </p:nvSpPr>
+        <p:spPr>
+          <a:xfrm>
+            <a:off x="5823444" y="2697480"/>
+            <a:ext cx="30000" cy="960120"/>
           </a:xfrm>
           <a:prstGeom prst="rect">
             <a:avLst/>
@@ -3767,13 +4356,57 @@
       </p:sp>
       <p:sp>
         <p:nvSpPr>
-          <p:cNvPr id="10" name="Right Arrow 9"/>
+          <p:cNvPr id="17" name="Rectangle 16"/>
           <p:cNvSpPr/>
           <p:nvPr/>
         </p:nvSpPr>
         <p:spPr>
           <a:xfrm>
-            <a:off x="4599432" y="2884932"/>
+            <a:off x="6821424" y="2014540"/>
+            <a:ext cx="146304" cy="40000"/>
+          </a:xfrm>
+          <a:prstGeom prst="rect">
+            <a:avLst/>
+          </a:prstGeom>
+          <a:solidFill>
+            <a:srgbClr val="0D7A6F"/>
+          </a:solidFill>
+          <a:ln>
+            <a:noFill/>
+          </a:ln>
+          <a:effectLst/>
+        </p:spPr>
+        <p:style>
+          <a:lnRef idx="1">
+            <a:schemeClr val="accent1"/>
+          </a:lnRef>
+          <a:fillRef idx="3">
+            <a:schemeClr val="accent1"/>
+          </a:fillRef>
+          <a:effectRef idx="2">
+            <a:schemeClr val="accent1"/>
+          </a:effectRef>
+          <a:fontRef idx="minor">
+            <a:schemeClr val="lt1"/>
+          </a:fontRef>
+        </p:style>
+        <p:txBody>
+          <a:bodyPr rtlCol="0" anchor="ctr"/>
+          <a:lstStyle/>
+          <a:p>
+            <a:pPr algn="ctr"/>
+          </a:p>
+        </p:txBody>
+      </p:sp>
+      <p:sp>
+        <p:nvSpPr>
+          <p:cNvPr id="18" name="Right Arrow 17"/>
+          <p:cNvSpPr/>
+          <p:nvPr/>
+        </p:nvSpPr>
+        <p:spPr>
+          <a:xfrm>
+            <a:off x="6876288" y="1924812"/>
             <a:ext cx="256032" cy="219456"/>
           </a:xfrm>
           <a:prstGeom prst="rightArrow">
@@ -3811,14 +4444,14 @@
       </p:sp>
       <p:sp>
         <p:nvSpPr>
-          <p:cNvPr id="11" name="Rounded Rectangle 10"/>
+          <p:cNvPr id="19" name="Rounded Rectangle 18"/>
           <p:cNvSpPr/>
           <p:nvPr/>
         </p:nvSpPr>
         <p:spPr>
           <a:xfrm>
-            <a:off x="4800600" y="2377440"/>
-            <a:ext cx="1828800" cy="1234440"/>
+            <a:off x="7077456" y="1371600"/>
+            <a:ext cx="1965960" cy="1325880"/>
           </a:xfrm>
           <a:prstGeom prst="roundRect">
             <a:avLst/>
@@ -3846,44 +4479,111 @@
           </a:fontRef>
         </p:style>
         <p:txBody>
-          <a:bodyPr rtlCol="0" anchor="ctr" wrap="square"/>
+          <a:bodyPr rtlCol="0" anchor="ctr"/>
           <a:lstStyle/>
           <a:p>
             <a:pPr algn="ctr"/>
             <a:r>
-              <a:rPr sz="1400" b="1" i="0">
+              <a:rPr sz="1300" b="1">
                 <a:solidFill>
                   <a:srgbClr val="FFFFFF"/>
                 </a:solidFill>
                 <a:latin typeface="Calibri"/>
               </a:rPr>
-              <a:t>model store</a:t>
+              <a:t>4. Receber HTTP</a:t>
             </a:r>
           </a:p>
           <a:p>
             <a:pPr algn="ctr"/>
             <a:r>
-              <a:rPr sz="1400" b="1" i="0">
+              <a:rPr sz="1300" b="1">
                 <a:solidFill>
                   <a:srgbClr val="FFFFFF"/>
                 </a:solidFill>
                 <a:latin typeface="Calibri"/>
               </a:rPr>
-              <a:t>BentoML</a:t>
-            </a:r>
-          </a:p>
-        </p:txBody>
-      </p:sp>
-      <p:sp>
-        <p:nvSpPr>
-          <p:cNvPr id="12" name="Rectangle 11"/>
+              <a:t>e montar lista</a:t>
+            </a:r>
+          </a:p>
+        </p:txBody>
+      </p:sp>
+      <p:sp>
+        <p:nvSpPr>
+          <p:cNvPr id="20" name="Rounded Rectangle 19"/>
           <p:cNvSpPr/>
           <p:nvPr/>
         </p:nvSpPr>
         <p:spPr>
           <a:xfrm>
-            <a:off x="6629400" y="2974660"/>
-            <a:ext cx="210312" cy="40000"/>
+            <a:off x="7077456" y="3657600"/>
+            <a:ext cx="1965960" cy="1325880"/>
+          </a:xfrm>
+          <a:prstGeom prst="roundRect">
+            <a:avLst/>
+          </a:prstGeom>
+          <a:solidFill>
+            <a:srgbClr val="E8F2F0"/>
+          </a:solidFill>
+          <a:ln w="15875">
+            <a:solidFill>
+              <a:srgbClr val="0D7A6F"/>
+            </a:solidFill>
+          </a:ln>
+          <a:effectLst/>
+        </p:spPr>
+        <p:style>
+          <a:lnRef idx="1">
+            <a:schemeClr val="accent1"/>
+          </a:lnRef>
+          <a:fillRef idx="3">
+            <a:schemeClr val="accent1"/>
+          </a:fillRef>
+          <a:effectRef idx="2">
+            <a:schemeClr val="accent1"/>
+          </a:effectRef>
+          <a:fontRef idx="minor">
+            <a:schemeClr val="lt1"/>
+          </a:fontRef>
+        </p:style>
+        <p:txBody>
+          <a:bodyPr rtlCol="0" anchor="ctr"/>
+          <a:lstStyle/>
+          <a:p>
+            <a:pPr algn="ctr"/>
+            <a:r>
+              <a:rPr sz="1300" b="1">
+                <a:solidFill>
+                  <a:srgbClr val="1A1A1A"/>
+                </a:solidFill>
+                <a:latin typeface="Consolas"/>
+              </a:rPr>
+              <a:t>service.py</a:t>
+            </a:r>
+          </a:p>
+          <a:p>
+            <a:pPr algn="ctr"/>
+            <a:r>
+              <a:rPr sz="1300" b="1">
+                <a:solidFill>
+                  <a:srgbClr val="1A1A1A"/>
+                </a:solidFill>
+                <a:latin typeface="Consolas"/>
+              </a:rPr>
+              <a:t>recomendar()</a:t>
+            </a:r>
+          </a:p>
+        </p:txBody>
+      </p:sp>
+      <p:sp>
+        <p:nvSpPr>
+          <p:cNvPr id="21" name="Rectangle 20"/>
+          <p:cNvSpPr/>
+          <p:nvPr/>
+        </p:nvSpPr>
+        <p:spPr>
+          <a:xfrm>
+            <a:off x="8045436" y="2697480"/>
+            <a:ext cx="30000" cy="960120"/>
           </a:xfrm>
           <a:prstGeom prst="rect">
             <a:avLst/>
@@ -3920,13 +4620,57 @@
       </p:sp>
       <p:sp>
         <p:nvSpPr>
-          <p:cNvPr id="13" name="Right Arrow 12"/>
+          <p:cNvPr id="22" name="Rectangle 21"/>
           <p:cNvSpPr/>
           <p:nvPr/>
         </p:nvSpPr>
         <p:spPr>
           <a:xfrm>
-            <a:off x="6748272" y="2884932"/>
+            <a:off x="9043416" y="2014540"/>
+            <a:ext cx="146304" cy="40000"/>
+          </a:xfrm>
+          <a:prstGeom prst="rect">
+            <a:avLst/>
+          </a:prstGeom>
+          <a:solidFill>
+            <a:srgbClr val="0D7A6F"/>
+          </a:solidFill>
+          <a:ln>
+            <a:noFill/>
+          </a:ln>
+          <a:effectLst/>
+        </p:spPr>
+        <p:style>
+          <a:lnRef idx="1">
+            <a:schemeClr val="accent1"/>
+          </a:lnRef>
+          <a:fillRef idx="3">
+            <a:schemeClr val="accent1"/>
+          </a:fillRef>
+          <a:effectRef idx="2">
+            <a:schemeClr val="accent1"/>
+          </a:effectRef>
+          <a:fontRef idx="minor">
+            <a:schemeClr val="lt1"/>
+          </a:fontRef>
+        </p:style>
+        <p:txBody>
+          <a:bodyPr rtlCol="0" anchor="ctr"/>
+          <a:lstStyle/>
+          <a:p>
+            <a:pPr algn="ctr"/>
+          </a:p>
+        </p:txBody>
+      </p:sp>
+      <p:sp>
+        <p:nvSpPr>
+          <p:cNvPr id="23" name="Right Arrow 22"/>
+          <p:cNvSpPr/>
+          <p:nvPr/>
+        </p:nvSpPr>
+        <p:spPr>
+          <a:xfrm>
+            <a:off x="9098280" y="1924812"/>
             <a:ext cx="256032" cy="219456"/>
           </a:xfrm>
           <a:prstGeom prst="rightArrow">
@@ -3964,14 +4708,14 @@
       </p:sp>
       <p:sp>
         <p:nvSpPr>
-          <p:cNvPr id="14" name="Rounded Rectangle 13"/>
+          <p:cNvPr id="24" name="Rounded Rectangle 23"/>
           <p:cNvSpPr/>
           <p:nvPr/>
         </p:nvSpPr>
         <p:spPr>
           <a:xfrm>
-            <a:off x="6949440" y="2377440"/>
-            <a:ext cx="1828800" cy="1234440"/>
+            <a:off x="9299448" y="1371600"/>
+            <a:ext cx="1965960" cy="1325880"/>
           </a:xfrm>
           <a:prstGeom prst="roundRect">
             <a:avLst/>
@@ -3999,44 +4743,111 @@
           </a:fontRef>
         </p:style>
         <p:txBody>
-          <a:bodyPr rtlCol="0" anchor="ctr" wrap="square"/>
+          <a:bodyPr rtlCol="0" anchor="ctr"/>
           <a:lstStyle/>
           <a:p>
             <a:pPr algn="ctr"/>
             <a:r>
-              <a:rPr sz="1400" b="1" i="0">
+              <a:rPr sz="1300" b="1">
                 <a:solidFill>
                   <a:srgbClr val="FFFFFF"/>
                 </a:solidFill>
                 <a:latin typeface="Calibri"/>
               </a:rPr>
-              <a:t>service.py</a:t>
+              <a:t>5. Devolver</a:t>
             </a:r>
           </a:p>
           <a:p>
             <a:pPr algn="ctr"/>
             <a:r>
-              <a:rPr sz="1400" b="1" i="0">
+              <a:rPr sz="1300" b="1">
                 <a:solidFill>
                   <a:srgbClr val="FFFFFF"/>
                 </a:solidFill>
                 <a:latin typeface="Calibri"/>
               </a:rPr>
-              <a:t>POST /recomendar</a:t>
-            </a:r>
-          </a:p>
-        </p:txBody>
-      </p:sp>
-      <p:sp>
-        <p:nvSpPr>
-          <p:cNvPr id="15" name="Rectangle 14"/>
+              <a:t>JSON</a:t>
+            </a:r>
+          </a:p>
+        </p:txBody>
+      </p:sp>
+      <p:sp>
+        <p:nvSpPr>
+          <p:cNvPr id="25" name="Rounded Rectangle 24"/>
           <p:cNvSpPr/>
           <p:nvPr/>
         </p:nvSpPr>
         <p:spPr>
           <a:xfrm>
-            <a:off x="8778240" y="2974660"/>
-            <a:ext cx="210312" cy="40000"/>
+            <a:off x="9299448" y="3657600"/>
+            <a:ext cx="1965960" cy="1325880"/>
+          </a:xfrm>
+          <a:prstGeom prst="roundRect">
+            <a:avLst/>
+          </a:prstGeom>
+          <a:solidFill>
+            <a:srgbClr val="E8F2F0"/>
+          </a:solidFill>
+          <a:ln w="15875">
+            <a:solidFill>
+              <a:srgbClr val="0D7A6F"/>
+            </a:solidFill>
+          </a:ln>
+          <a:effectLst/>
+        </p:spPr>
+        <p:style>
+          <a:lnRef idx="1">
+            <a:schemeClr val="accent1"/>
+          </a:lnRef>
+          <a:fillRef idx="3">
+            <a:schemeClr val="accent1"/>
+          </a:fillRef>
+          <a:effectRef idx="2">
+            <a:schemeClr val="accent1"/>
+          </a:effectRef>
+          <a:fontRef idx="minor">
+            <a:schemeClr val="lt1"/>
+          </a:fontRef>
+        </p:style>
+        <p:txBody>
+          <a:bodyPr rtlCol="0" anchor="ctr"/>
+          <a:lstStyle/>
+          <a:p>
+            <a:pPr algn="ctr"/>
+            <a:r>
+              <a:rPr sz="1300" b="1">
+                <a:solidFill>
+                  <a:srgbClr val="1A1A1A"/>
+                </a:solidFill>
+                <a:latin typeface="Consolas"/>
+              </a:rPr>
+              <a:t>resposta</a:t>
+            </a:r>
+          </a:p>
+          <a:p>
+            <a:pPr algn="ctr"/>
+            <a:r>
+              <a:rPr sz="1300" b="1">
+                <a:solidFill>
+                  <a:srgbClr val="1A1A1A"/>
+                </a:solidFill>
+                <a:latin typeface="Consolas"/>
+              </a:rPr>
+              <a:t>items[]</a:t>
+            </a:r>
+          </a:p>
+        </p:txBody>
+      </p:sp>
+      <p:sp>
+        <p:nvSpPr>
+          <p:cNvPr id="26" name="Rectangle 25"/>
+          <p:cNvSpPr/>
+          <p:nvPr/>
+        </p:nvSpPr>
+        <p:spPr>
+          <a:xfrm>
+            <a:off x="10267428" y="2697480"/>
+            <a:ext cx="30000" cy="960120"/>
           </a:xfrm>
           <a:prstGeom prst="rect">
             <a:avLst/>
@@ -4073,194 +4884,14 @@
       </p:sp>
       <p:sp>
         <p:nvSpPr>
-          <p:cNvPr id="16" name="Right Arrow 15"/>
-          <p:cNvSpPr/>
-          <p:nvPr/>
-        </p:nvSpPr>
-        <p:spPr>
-          <a:xfrm>
-            <a:off x="8897112" y="2884932"/>
-            <a:ext cx="256032" cy="219456"/>
-          </a:xfrm>
-          <a:prstGeom prst="rightArrow">
-            <a:avLst/>
-          </a:prstGeom>
-          <a:solidFill>
-            <a:srgbClr val="0D7A6F"/>
-          </a:solidFill>
-          <a:ln>
-            <a:noFill/>
-          </a:ln>
-          <a:effectLst/>
-        </p:spPr>
-        <p:style>
-          <a:lnRef idx="1">
-            <a:schemeClr val="accent1"/>
-          </a:lnRef>
-          <a:fillRef idx="3">
-            <a:schemeClr val="accent1"/>
-          </a:fillRef>
-          <a:effectRef idx="2">
-            <a:schemeClr val="accent1"/>
-          </a:effectRef>
-          <a:fontRef idx="minor">
-            <a:schemeClr val="lt1"/>
-          </a:fontRef>
-        </p:style>
-        <p:txBody>
-          <a:bodyPr rtlCol="0" anchor="ctr"/>
-          <a:lstStyle/>
-          <a:p>
-            <a:pPr algn="ctr"/>
-          </a:p>
-        </p:txBody>
-      </p:sp>
-      <p:sp>
-        <p:nvSpPr>
-          <p:cNvPr id="17" name="Rounded Rectangle 16"/>
-          <p:cNvSpPr/>
-          <p:nvPr/>
-        </p:nvSpPr>
-        <p:spPr>
-          <a:xfrm>
-            <a:off x="9098280" y="2377440"/>
-            <a:ext cx="1828800" cy="1234440"/>
-          </a:xfrm>
-          <a:prstGeom prst="roundRect">
-            <a:avLst/>
-          </a:prstGeom>
-          <a:solidFill>
-            <a:srgbClr val="E8F2F0"/>
-          </a:solidFill>
-          <a:ln>
-            <a:noFill/>
-          </a:ln>
-          <a:effectLst/>
-        </p:spPr>
-        <p:style>
-          <a:lnRef idx="1">
-            <a:schemeClr val="accent1"/>
-          </a:lnRef>
-          <a:fillRef idx="3">
-            <a:schemeClr val="accent1"/>
-          </a:fillRef>
-          <a:effectRef idx="2">
-            <a:schemeClr val="accent1"/>
-          </a:effectRef>
-          <a:fontRef idx="minor">
-            <a:schemeClr val="lt1"/>
-          </a:fontRef>
-        </p:style>
-        <p:txBody>
-          <a:bodyPr rtlCol="0" anchor="ctr" wrap="square"/>
-          <a:lstStyle/>
-          <a:p>
-            <a:pPr algn="ctr"/>
-            <a:r>
-              <a:rPr sz="1400" b="1" i="0">
-                <a:solidFill>
-                  <a:srgbClr val="1A1A1A"/>
-                </a:solidFill>
-                <a:latin typeface="Calibri"/>
-              </a:rPr>
-              <a:t>JSON</a:t>
-            </a:r>
-          </a:p>
-          <a:p>
-            <a:pPr algn="ctr"/>
-            <a:r>
-              <a:rPr sz="1400" b="1" i="0">
-                <a:solidFill>
-                  <a:srgbClr val="1A1A1A"/>
-                </a:solidFill>
-                <a:latin typeface="Calibri"/>
-              </a:rPr>
-              <a:t>items[]</a:t>
-            </a:r>
-          </a:p>
-        </p:txBody>
-      </p:sp>
-      <p:sp>
-        <p:nvSpPr>
-          <p:cNvPr id="18" name="TextBox 17"/>
+          <p:cNvPr id="27" name="TextBox 26"/>
           <p:cNvSpPr txBox="1"/>
           <p:nvPr/>
         </p:nvSpPr>
         <p:spPr>
           <a:xfrm>
-            <a:off x="640080" y="4114800"/>
-            <a:ext cx="10972800" cy="1828800"/>
-          </a:xfrm>
-          <a:prstGeom prst="rect">
-            <a:avLst/>
-          </a:prstGeom>
-          <a:noFill/>
-        </p:spPr>
-        <p:txBody>
-          <a:bodyPr wrap="square" lIns="50800" rIns="50800" tIns="25400" bIns="25400">
-            <a:spAutoFit/>
-          </a:bodyPr>
-          <a:lstStyle/>
-          <a:p>
-            <a:pPr algn="l">
-              <a:spcAft>
-                <a:spcPts val="400"/>
-              </a:spcAft>
-            </a:pPr>
-            <a:r>
-              <a:rPr sz="1800" b="0" i="0">
-                <a:solidFill>
-                  <a:srgbClr val="1A1A1A"/>
-                </a:solidFill>
-                <a:latin typeface="Calibri"/>
-              </a:rPr>
-              <a:t>Regra em linguagem natural</a:t>
-            </a:r>
-          </a:p>
-          <a:p>
-            <a:pPr algn="l">
-              <a:spcAft>
-                <a:spcPts val="400"/>
-              </a:spcAft>
-            </a:pPr>
-            <a:r>
-              <a:rPr sz="1800" b="0" i="0">
-                <a:solidFill>
-                  <a:srgbClr val="1A1A1A"/>
-                </a:solidFill>
-                <a:latin typeface="Calibri"/>
-              </a:rPr>
-              <a:t>1. Filtrar mesma técnica · 2. Ordenar por pedidos (+ co-ocorrência) ·</a:t>
-            </a:r>
-          </a:p>
-          <a:p>
-            <a:pPr algn="l">
-              <a:spcAft>
-                <a:spcPts val="400"/>
-              </a:spcAft>
-            </a:pPr>
-            <a:r>
-              <a:rPr sz="1800" b="0" i="0">
-                <a:solidFill>
-                  <a:srgbClr val="1A1A1A"/>
-                </a:solidFill>
-                <a:latin typeface="Calibri"/>
-              </a:rPr>
-              <a:t>3. Se faltar vaga, completar com os mais pedidos do catálogo.</a:t>
-            </a:r>
-          </a:p>
-        </p:txBody>
-      </p:sp>
-      <p:sp>
-        <p:nvSpPr>
-          <p:cNvPr id="19" name="TextBox 18"/>
-          <p:cNvSpPr txBox="1"/>
-          <p:nvPr/>
-        </p:nvSpPr>
-        <p:spPr>
-          <a:xfrm>
-            <a:off x="640080" y="6126480"/>
-            <a:ext cx="10972800" cy="365760"/>
+            <a:off x="548640" y="5303520"/>
+            <a:ext cx="10972800" cy="640080"/>
           </a:xfrm>
           <a:prstGeom prst="rect">
             <a:avLst/>
@@ -4279,13 +4910,52 @@
               </a:spcAft>
             </a:pPr>
             <a:r>
-              <a:rPr sz="1200" b="0" i="0">
+              <a:rPr sz="1600" b="0">
                 <a:solidFill>
                   <a:srgbClr val="4A5558"/>
                 </a:solidFill>
                 <a:latin typeface="Calibri"/>
               </a:rPr>
-              <a:t>2 / 5  ·  diagrama</a:t>
+              <a:t>Linha de cima = o que acontece · linha de baixo = arquivo ou peça do sistema</a:t>
+            </a:r>
+          </a:p>
+        </p:txBody>
+      </p:sp>
+      <p:sp>
+        <p:nvSpPr>
+          <p:cNvPr id="28" name="TextBox 27"/>
+          <p:cNvSpPr txBox="1"/>
+          <p:nvPr/>
+        </p:nvSpPr>
+        <p:spPr>
+          <a:xfrm>
+            <a:off x="548640" y="6126480"/>
+            <a:ext cx="10972800" cy="320040"/>
+          </a:xfrm>
+          <a:prstGeom prst="rect">
+            <a:avLst/>
+          </a:prstGeom>
+          <a:noFill/>
+        </p:spPr>
+        <p:txBody>
+          <a:bodyPr wrap="square" lIns="50800" rIns="50800" tIns="25400" bIns="25400">
+            <a:spAutoFit/>
+          </a:bodyPr>
+          <a:lstStyle/>
+          <a:p>
+            <a:pPr algn="l">
+              <a:spcAft>
+                <a:spcPts val="800"/>
+              </a:spcAft>
+            </a:pPr>
+            <a:r>
+              <a:rPr sz="1200" b="0">
+                <a:solidFill>
+                  <a:srgbClr val="4A5558"/>
+                </a:solidFill>
+                <a:latin typeface="Calibri"/>
+              </a:rPr>
+              <a:t>2 / 5</a:t>
             </a:r>
           </a:p>
         </p:txBody>
@@ -4359,8 +5029,8 @@
         </p:nvSpPr>
         <p:spPr>
           <a:xfrm>
-            <a:off x="640080" y="274320"/>
-            <a:ext cx="10972800" cy="502920"/>
+            <a:off x="502920" y="228600"/>
+            <a:ext cx="11155680" cy="457200"/>
           </a:xfrm>
           <a:prstGeom prst="rect">
             <a:avLst/>
@@ -4379,27 +5049,66 @@
               </a:spcAft>
             </a:pPr>
             <a:r>
-              <a:rPr sz="2800" b="1" i="0">
+              <a:rPr sz="2600" b="1">
                 <a:solidFill>
                   <a:srgbClr val="1A1A1A"/>
                 </a:solidFill>
                 <a:latin typeface="Georgia"/>
               </a:rPr>
-              <a:t>Conta trabalhada — âncora p01 (cerâmica)</a:t>
-            </a:r>
-          </a:p>
-        </p:txBody>
-      </p:sp>
-      <p:sp>
-        <p:nvSpPr>
-          <p:cNvPr id="4" name="Rounded Rectangle 3"/>
+              <a:t>Exemplo: cliente abriu o Jarro de barro</a:t>
+            </a:r>
+          </a:p>
+        </p:txBody>
+      </p:sp>
+      <p:sp>
+        <p:nvSpPr>
+          <p:cNvPr id="4" name="TextBox 3"/>
+          <p:cNvSpPr txBox="1"/>
+          <p:nvPr/>
+        </p:nvSpPr>
+        <p:spPr>
+          <a:xfrm>
+            <a:off x="502920" y="731520"/>
+            <a:ext cx="11155680" cy="365760"/>
+          </a:xfrm>
+          <a:prstGeom prst="rect">
+            <a:avLst/>
+          </a:prstGeom>
+          <a:noFill/>
+        </p:spPr>
+        <p:txBody>
+          <a:bodyPr wrap="square" lIns="50800" rIns="50800" tIns="25400" bIns="25400">
+            <a:spAutoFit/>
+          </a:bodyPr>
+          <a:lstStyle/>
+          <a:p>
+            <a:pPr algn="l">
+              <a:spcAft>
+                <a:spcPts val="800"/>
+              </a:spcAft>
+            </a:pPr>
+            <a:r>
+              <a:rPr sz="1500" b="0">
+                <a:solidFill>
+                  <a:srgbClr val="4A5558"/>
+                </a:solidFill>
+                <a:latin typeface="Calibri"/>
+              </a:rPr>
+              <a:t>produto_na_pagina = p01 · técnica = cerâmica · pedimos 4 sugestões</a:t>
+            </a:r>
+          </a:p>
+        </p:txBody>
+      </p:sp>
+      <p:sp>
+        <p:nvSpPr>
+          <p:cNvPr id="5" name="Rounded Rectangle 4"/>
           <p:cNvSpPr/>
           <p:nvPr/>
         </p:nvSpPr>
         <p:spPr>
           <a:xfrm>
-            <a:off x="502920" y="1005840"/>
-            <a:ext cx="5486400" cy="4754880"/>
+            <a:off x="457200" y="1234440"/>
+            <a:ext cx="5669280" cy="4480560"/>
           </a:xfrm>
           <a:prstGeom prst="roundRect">
             <a:avLst/>
@@ -4438,14 +5147,14 @@
       </p:sp>
       <p:sp>
         <p:nvSpPr>
-          <p:cNvPr id="5" name="TextBox 4"/>
+          <p:cNvPr id="6" name="TextBox 5"/>
           <p:cNvSpPr txBox="1"/>
           <p:nvPr/>
         </p:nvSpPr>
         <p:spPr>
           <a:xfrm>
-            <a:off x="685800" y="1143000"/>
-            <a:ext cx="5120640" cy="4480560"/>
+            <a:off x="640080" y="1371600"/>
+            <a:ext cx="5303520" cy="4206240"/>
           </a:xfrm>
           <a:prstGeom prst="rect">
             <a:avLst/>
@@ -4464,13 +5173,13 @@
               </a:spcAft>
             </a:pPr>
             <a:r>
-              <a:rPr sz="1600" b="0" i="0">
+              <a:rPr sz="1500" b="0">
                 <a:solidFill>
                   <a:srgbClr val="1A1A1A"/>
                 </a:solidFill>
-                <a:latin typeface="Consolas"/>
-              </a:rPr>
-              <a:t>pop_norm = pedidos / 42</a:t>
+                <a:latin typeface="Calibri"/>
+              </a:rPr>
+              <a:t>1. Outros de cerâmica: Prato, Boneca</a:t>
             </a:r>
           </a:p>
           <a:p>
@@ -4480,13 +5189,13 @@
               </a:spcAft>
             </a:pPr>
             <a:r>
-              <a:rPr sz="1600" b="0" i="0">
+              <a:rPr sz="1500" b="0">
                 <a:solidFill>
                   <a:srgbClr val="1A1A1A"/>
                 </a:solidFill>
-                <a:latin typeface="Consolas"/>
-              </a:rPr>
-              <a:t>p02: 28/42 ≈ 0,6667</a:t>
+                <a:latin typeface="Calibri"/>
+              </a:rPr>
+              <a:t>   (só 2 — ainda faltam vagas)</a:t>
             </a:r>
           </a:p>
           <a:p>
@@ -4496,13 +5205,13 @@
               </a:spcAft>
             </a:pPr>
             <a:r>
-              <a:rPr sz="1600" b="0" i="0">
+              <a:rPr sz="1500" b="0">
                 <a:solidFill>
                   <a:srgbClr val="1A1A1A"/>
                 </a:solidFill>
-                <a:latin typeface="Consolas"/>
-              </a:rPr>
-              <a:t>p03: 19/42 ≈ 0,4524</a:t>
+                <a:latin typeface="Calibri"/>
+              </a:rPr>
+              <a:t/>
             </a:r>
           </a:p>
           <a:p>
@@ -4512,13 +5221,13 @@
               </a:spcAft>
             </a:pPr>
             <a:r>
-              <a:rPr sz="1600" b="0" i="0">
+              <a:rPr sz="1500" b="0">
                 <a:solidFill>
                   <a:srgbClr val="1A1A1A"/>
                 </a:solidFill>
-                <a:latin typeface="Consolas"/>
-              </a:rPr>
-              <a:t/>
+                <a:latin typeface="Calibri"/>
+              </a:rPr>
+              <a:t>2. Nota = 0,7×popularidade + 0,3×juntos</a:t>
             </a:r>
           </a:p>
           <a:p>
@@ -4528,13 +5237,13 @@
               </a:spcAft>
             </a:pPr>
             <a:r>
-              <a:rPr sz="1600" b="0" i="0">
+              <a:rPr sz="1500" b="0">
                 <a:solidFill>
                   <a:srgbClr val="1A1A1A"/>
                 </a:solidFill>
-                <a:latin typeface="Consolas"/>
-              </a:rPr>
-              <a:t>sim(p01,p02)=1,00  sim(p01,p03)≈0,67</a:t>
+                <a:latin typeface="Calibri"/>
+              </a:rPr>
+              <a:t>   Prato ≈ 0,77 · Boneca ≈ 0,52</a:t>
             </a:r>
           </a:p>
           <a:p>
@@ -4544,11 +5253,11 @@
               </a:spcAft>
             </a:pPr>
             <a:r>
-              <a:rPr sz="1600" b="0" i="0">
+              <a:rPr sz="1500" b="0">
                 <a:solidFill>
                   <a:srgbClr val="1A1A1A"/>
                 </a:solidFill>
-                <a:latin typeface="Consolas"/>
+                <a:latin typeface="Calibri"/>
               </a:rPr>
               <a:t/>
             </a:r>
@@ -4560,13 +5269,13 @@
               </a:spcAft>
             </a:pPr>
             <a:r>
-              <a:rPr sz="1600" b="0" i="0">
+              <a:rPr sz="1500" b="0">
                 <a:solidFill>
                   <a:srgbClr val="1A1A1A"/>
                 </a:solidFill>
-                <a:latin typeface="Consolas"/>
-              </a:rPr>
-              <a:t>mesma técnica:</a:t>
+                <a:latin typeface="Calibri"/>
+              </a:rPr>
+              <a:t>3. Completar com os mais pedidos:</a:t>
             </a:r>
           </a:p>
           <a:p>
@@ -4576,13 +5285,13 @@
               </a:spcAft>
             </a:pPr>
             <a:r>
-              <a:rPr sz="1600" b="0" i="0">
+              <a:rPr sz="1500" b="0">
                 <a:solidFill>
                   <a:srgbClr val="1A1A1A"/>
                 </a:solidFill>
-                <a:latin typeface="Consolas"/>
-              </a:rPr>
-              <a:t>score = 0,7·pop_norm + 0,3·sim</a:t>
+                <a:latin typeface="Calibri"/>
+              </a:rPr>
+              <a:t>   Rendeira ≈ 0,42 · Xilogravura ≈ 0,37</a:t>
             </a:r>
           </a:p>
           <a:p>
@@ -4592,11 +5301,11 @@
               </a:spcAft>
             </a:pPr>
             <a:r>
-              <a:rPr sz="1600" b="0" i="0">
+              <a:rPr sz="1500" b="0">
                 <a:solidFill>
                   <a:srgbClr val="1A1A1A"/>
                 </a:solidFill>
-                <a:latin typeface="Consolas"/>
+                <a:latin typeface="Calibri"/>
               </a:rPr>
               <a:t/>
             </a:r>
@@ -4608,13 +5317,13 @@
               </a:spcAft>
             </a:pPr>
             <a:r>
-              <a:rPr sz="1600" b="0" i="0">
+              <a:rPr sz="1500" b="0">
                 <a:solidFill>
                   <a:srgbClr val="1A1A1A"/>
                 </a:solidFill>
-                <a:latin typeface="Consolas"/>
-              </a:rPr>
-              <a:t>p02: 0,7·0,6667 + 0,3·1 = 0,7667</a:t>
+                <a:latin typeface="Calibri"/>
+              </a:rPr>
+              <a:t>Detalhe das contas:</a:t>
             </a:r>
           </a:p>
           <a:p>
@@ -4624,75 +5333,27 @@
               </a:spcAft>
             </a:pPr>
             <a:r>
-              <a:rPr sz="1600" b="0" i="0">
+              <a:rPr sz="1500" b="0">
                 <a:solidFill>
                   <a:srgbClr val="1A1A1A"/>
                 </a:solidFill>
-                <a:latin typeface="Consolas"/>
-              </a:rPr>
-              <a:t>p03: 0,7·0,4524 + 0,3·0,67 ≈ 0,5167</a:t>
-            </a:r>
-          </a:p>
-          <a:p>
-            <a:pPr algn="l">
-              <a:spcAft>
-                <a:spcPts val="300"/>
-              </a:spcAft>
-            </a:pPr>
-            <a:r>
-              <a:rPr sz="1600" b="0" i="0">
-                <a:solidFill>
-                  <a:srgbClr val="1A1A1A"/>
-                </a:solidFill>
-                <a:latin typeface="Consolas"/>
-              </a:rPr>
-              <a:t/>
-            </a:r>
-          </a:p>
-          <a:p>
-            <a:pPr algn="l">
-              <a:spcAft>
-                <a:spcPts val="300"/>
-              </a:spcAft>
-            </a:pPr>
-            <a:r>
-              <a:rPr sz="1600" b="0" i="0">
-                <a:solidFill>
-                  <a:srgbClr val="1A1A1A"/>
-                </a:solidFill>
-                <a:latin typeface="Consolas"/>
-              </a:rPr>
-              <a:t>Só 2 cerâmicas → fallback</a:t>
-            </a:r>
-          </a:p>
-          <a:p>
-            <a:pPr algn="l">
-              <a:spcAft>
-                <a:spcPts val="300"/>
-              </a:spcAft>
-            </a:pPr>
-            <a:r>
-              <a:rPr sz="1600" b="0" i="0">
-                <a:solidFill>
-                  <a:srgbClr val="1A1A1A"/>
-                </a:solidFill>
-                <a:latin typeface="Consolas"/>
-              </a:rPr>
-              <a:t>p04, p07 com score = 0,5·pop_norm</a:t>
-            </a:r>
-          </a:p>
-        </p:txBody>
-      </p:sp>
-      <p:sp>
-        <p:nvSpPr>
-          <p:cNvPr id="6" name="Rounded Rectangle 5"/>
+                <a:latin typeface="Calibri"/>
+              </a:rPr>
+              <a:t>material/calculos-trabalhados.md</a:t>
+            </a:r>
+          </a:p>
+        </p:txBody>
+      </p:sp>
+      <p:sp>
+        <p:nvSpPr>
+          <p:cNvPr id="7" name="Rounded Rectangle 6"/>
           <p:cNvSpPr/>
           <p:nvPr/>
         </p:nvSpPr>
         <p:spPr>
           <a:xfrm>
-            <a:off x="6309360" y="1005840"/>
-            <a:ext cx="5303520" cy="4754880"/>
+            <a:off x="6400800" y="1234440"/>
+            <a:ext cx="5212080" cy="4480560"/>
           </a:xfrm>
           <a:prstGeom prst="roundRect">
             <a:avLst/>
@@ -4729,14 +5390,14 @@
       </p:sp>
       <p:sp>
         <p:nvSpPr>
-          <p:cNvPr id="7" name="TextBox 6"/>
+          <p:cNvPr id="8" name="TextBox 7"/>
           <p:cNvSpPr txBox="1"/>
           <p:nvPr/>
         </p:nvSpPr>
         <p:spPr>
           <a:xfrm>
-            <a:off x="6492240" y="1188720"/>
-            <a:ext cx="4937760" cy="4389120"/>
+            <a:off x="6583680" y="1417320"/>
+            <a:ext cx="4846320" cy="4114800"/>
           </a:xfrm>
           <a:prstGeom prst="rect">
             <a:avLst/>
@@ -4751,31 +5412,31 @@
           <a:p>
             <a:pPr algn="l">
               <a:spcAft>
-                <a:spcPts val="400"/>
+                <a:spcPts val="500"/>
               </a:spcAft>
             </a:pPr>
             <a:r>
-              <a:rPr sz="1700" b="0" i="0">
+              <a:rPr sz="1700" b="0">
                 <a:solidFill>
                   <a:srgbClr val="FFFFFF"/>
                 </a:solidFill>
-                <a:latin typeface="Consolas"/>
-              </a:rPr>
-              <a:t>Resposta (ordem)</a:t>
+                <a:latin typeface="Calibri"/>
+              </a:rPr>
+              <a:t>Lista devolvida</a:t>
             </a:r>
           </a:p>
           <a:p>
             <a:pPr algn="l">
               <a:spcAft>
-                <a:spcPts val="400"/>
+                <a:spcPts val="500"/>
               </a:spcAft>
             </a:pPr>
             <a:r>
-              <a:rPr sz="1700" b="0" i="0">
+              <a:rPr sz="1700" b="0">
                 <a:solidFill>
                   <a:srgbClr val="FFFFFF"/>
                 </a:solidFill>
-                <a:latin typeface="Consolas"/>
+                <a:latin typeface="Calibri"/>
               </a:rPr>
               <a:t/>
             </a:r>
@@ -4783,79 +5444,79 @@
           <a:p>
             <a:pPr algn="l">
               <a:spcAft>
-                <a:spcPts val="400"/>
+                <a:spcPts val="500"/>
               </a:spcAft>
             </a:pPr>
             <a:r>
-              <a:rPr sz="1700" b="0" i="0">
+              <a:rPr sz="1700" b="0">
                 <a:solidFill>
                   <a:srgbClr val="FFFFFF"/>
                 </a:solidFill>
-                <a:latin typeface="Consolas"/>
-              </a:rPr>
-              <a:t>1  p02  mesma_tecnica   0,7667</a:t>
+                <a:latin typeface="Calibri"/>
+              </a:rPr>
+              <a:t>1  Prato esmaltado</a:t>
             </a:r>
           </a:p>
           <a:p>
             <a:pPr algn="l">
               <a:spcAft>
-                <a:spcPts val="400"/>
+                <a:spcPts val="500"/>
               </a:spcAft>
             </a:pPr>
             <a:r>
-              <a:rPr sz="1700" b="0" i="0">
+              <a:rPr sz="1700" b="0">
                 <a:solidFill>
                   <a:srgbClr val="FFFFFF"/>
                 </a:solidFill>
-                <a:latin typeface="Consolas"/>
-              </a:rPr>
-              <a:t>2  p03  mesma_tecnica   0,5167</a:t>
+                <a:latin typeface="Calibri"/>
+              </a:rPr>
+              <a:t>2  Boneca de barro</a:t>
             </a:r>
           </a:p>
           <a:p>
             <a:pPr algn="l">
               <a:spcAft>
-                <a:spcPts val="400"/>
+                <a:spcPts val="500"/>
               </a:spcAft>
             </a:pPr>
             <a:r>
-              <a:rPr sz="1700" b="0" i="0">
+              <a:rPr sz="1700" b="0">
                 <a:solidFill>
                   <a:srgbClr val="FFFFFF"/>
                 </a:solidFill>
-                <a:latin typeface="Consolas"/>
-              </a:rPr>
-              <a:t>3  p04  fallback        0,4167</a:t>
+                <a:latin typeface="Calibri"/>
+              </a:rPr>
+              <a:t>3  Rendeira Alto do Moura</a:t>
             </a:r>
           </a:p>
           <a:p>
             <a:pPr algn="l">
               <a:spcAft>
-                <a:spcPts val="400"/>
+                <a:spcPts val="500"/>
               </a:spcAft>
             </a:pPr>
             <a:r>
-              <a:rPr sz="1700" b="0" i="0">
+              <a:rPr sz="1700" b="0">
                 <a:solidFill>
                   <a:srgbClr val="FFFFFF"/>
                 </a:solidFill>
-                <a:latin typeface="Consolas"/>
-              </a:rPr>
-              <a:t>4  p07  fallback        0,3690</a:t>
+                <a:latin typeface="Calibri"/>
+              </a:rPr>
+              <a:t>4  Xilogravura Pilar</a:t>
             </a:r>
           </a:p>
           <a:p>
             <a:pPr algn="l">
               <a:spcAft>
-                <a:spcPts val="400"/>
+                <a:spcPts val="500"/>
               </a:spcAft>
             </a:pPr>
             <a:r>
-              <a:rPr sz="1700" b="0" i="0">
+              <a:rPr sz="1700" b="0">
                 <a:solidFill>
                   <a:srgbClr val="FFFFFF"/>
                 </a:solidFill>
-                <a:latin typeface="Consolas"/>
+                <a:latin typeface="Calibri"/>
               </a:rPr>
               <a:t/>
             </a:r>
@@ -4863,79 +5524,31 @@
           <a:p>
             <a:pPr algn="l">
               <a:spcAft>
-                <a:spcPts val="400"/>
+                <a:spcPts val="500"/>
               </a:spcAft>
             </a:pPr>
             <a:r>
-              <a:rPr sz="1700" b="0" i="0">
+              <a:rPr sz="1700" b="0">
                 <a:solidFill>
                   <a:srgbClr val="FFFFFF"/>
                 </a:solidFill>
-                <a:latin typeface="Consolas"/>
-              </a:rPr>
-              <a:t>fallback_used = true</a:t>
-            </a:r>
-          </a:p>
-          <a:p>
-            <a:pPr algn="l">
-              <a:spcAft>
-                <a:spcPts val="400"/>
-              </a:spcAft>
-            </a:pPr>
-            <a:r>
-              <a:rPr sz="1700" b="0" i="0">
-                <a:solidFill>
-                  <a:srgbClr val="FFFFFF"/>
-                </a:solidFill>
-                <a:latin typeface="Consolas"/>
-              </a:rPr>
-              <a:t/>
-            </a:r>
-          </a:p>
-          <a:p>
-            <a:pPr algn="l">
-              <a:spcAft>
-                <a:spcPts val="400"/>
-              </a:spcAft>
-            </a:pPr>
-            <a:r>
-              <a:rPr sz="1700" b="0" i="0">
-                <a:solidFill>
-                  <a:srgbClr val="FFFFFF"/>
-                </a:solidFill>
-                <a:latin typeface="Consolas"/>
-              </a:rPr>
-              <a:t>Detalhe: material/</a:t>
-            </a:r>
-          </a:p>
-          <a:p>
-            <a:pPr algn="l">
-              <a:spcAft>
-                <a:spcPts val="400"/>
-              </a:spcAft>
-            </a:pPr>
-            <a:r>
-              <a:rPr sz="1700" b="0" i="0">
-                <a:solidFill>
-                  <a:srgbClr val="FFFFFF"/>
-                </a:solidFill>
-                <a:latin typeface="Consolas"/>
-              </a:rPr>
-              <a:t>calculos-trabalhados.md</a:t>
-            </a:r>
-          </a:p>
-        </p:txBody>
-      </p:sp>
-      <p:sp>
-        <p:nvSpPr>
-          <p:cNvPr id="8" name="TextBox 7"/>
+                <a:latin typeface="Calibri"/>
+              </a:rPr>
+              <a:t>just curl-exemplo</a:t>
+            </a:r>
+          </a:p>
+        </p:txBody>
+      </p:sp>
+      <p:sp>
+        <p:nvSpPr>
+          <p:cNvPr id="9" name="TextBox 8"/>
           <p:cNvSpPr txBox="1"/>
           <p:nvPr/>
         </p:nvSpPr>
         <p:spPr>
           <a:xfrm>
-            <a:off x="640080" y="6126480"/>
-            <a:ext cx="10972800" cy="365760"/>
+            <a:off x="502920" y="6126480"/>
+            <a:ext cx="10972800" cy="320040"/>
           </a:xfrm>
           <a:prstGeom prst="rect">
             <a:avLst/>
@@ -4954,13 +5567,13 @@
               </a:spcAft>
             </a:pPr>
             <a:r>
-              <a:rPr sz="1200" b="0" i="0">
+              <a:rPr sz="1200" b="0">
                 <a:solidFill>
                   <a:srgbClr val="4A5558"/>
                 </a:solidFill>
                 <a:latin typeface="Calibri"/>
               </a:rPr>
-              <a:t>3 / 5  ·  exemplo numérico</a:t>
+              <a:t>3 / 5</a:t>
             </a:r>
           </a:p>
         </p:txBody>
@@ -5034,7 +5647,7 @@
         </p:nvSpPr>
         <p:spPr>
           <a:xfrm>
-            <a:off x="640080" y="274320"/>
+            <a:off x="548640" y="274320"/>
             <a:ext cx="10972800" cy="457200"/>
           </a:xfrm>
           <a:prstGeom prst="rect">
@@ -5054,13 +5667,13 @@
               </a:spcAft>
             </a:pPr>
             <a:r>
-              <a:rPr sz="2800" b="1" i="0">
+              <a:rPr sz="2800" b="1">
                 <a:solidFill>
                   <a:srgbClr val="FFFFFF"/>
                 </a:solidFill>
                 <a:latin typeface="Georgia"/>
               </a:rPr>
-              <a:t>Código comentado — o miolo do serviço</a:t>
+              <a:t>Mesmos passos no código</a:t>
             </a:r>
           </a:p>
         </p:txBody>
@@ -5073,8 +5686,8 @@
         </p:nvSpPr>
         <p:spPr>
           <a:xfrm>
-            <a:off x="640080" y="1005840"/>
-            <a:ext cx="10972800" cy="3291840"/>
+            <a:off x="548640" y="914400"/>
+            <a:ext cx="11064240" cy="4754880"/>
           </a:xfrm>
           <a:prstGeom prst="roundRect">
             <a:avLst/>
@@ -5117,8 +5730,8 @@
         </p:nvSpPr>
         <p:spPr>
           <a:xfrm>
-            <a:off x="868680" y="1188720"/>
-            <a:ext cx="10515600" cy="3017520"/>
+            <a:off x="777240" y="1097280"/>
+            <a:ext cx="10607040" cy="4389120"/>
           </a:xfrm>
           <a:prstGeom prst="rect">
             <a:avLst/>
@@ -5133,113 +5746,145 @@
           <a:p>
             <a:pPr algn="l">
               <a:spcAft>
-                <a:spcPts val="600"/>
+                <a:spcPts val="500"/>
               </a:spcAft>
             </a:pPr>
             <a:r>
-              <a:rPr sz="1800" b="0" i="0">
+              <a:rPr sz="1700" b="0">
                 <a:solidFill>
                   <a:srgbClr val="B8E0D8"/>
                 </a:solidFill>
                 <a:latin typeface="Consolas"/>
               </a:rPr>
-              <a:t>@bentoml.api</a:t>
+              <a:t># service.py — função recomendar</a:t>
             </a:r>
           </a:p>
           <a:p>
             <a:pPr algn="l">
               <a:spcAft>
-                <a:spcPts val="600"/>
+                <a:spcPts val="500"/>
               </a:spcAft>
             </a:pPr>
             <a:r>
-              <a:rPr sz="1800" b="0" i="0">
+              <a:rPr sz="1700" b="0">
                 <a:solidFill>
                   <a:srgbClr val="B8E0D8"/>
                 </a:solidFill>
                 <a:latin typeface="Consolas"/>
               </a:rPr>
-              <a:t>def recomendar(self, produto_ancora, limite=4, excluir=None):</a:t>
+              <a:t/>
             </a:r>
           </a:p>
           <a:p>
             <a:pPr algn="l">
               <a:spcAft>
-                <a:spcPts val="600"/>
+                <a:spcPts val="500"/>
               </a:spcAft>
             </a:pPr>
             <a:r>
-              <a:rPr sz="1800" b="0" i="0">
+              <a:rPr sz="1700" b="0">
                 <a:solidFill>
                   <a:srgbClr val="B8E0D8"/>
                 </a:solidFill>
                 <a:latin typeface="Consolas"/>
               </a:rPr>
-              <a:t>    # 1) candidatos = mesma técnica, sem âncora/excluir</a:t>
+              <a:t># passo 1  candidatos = mesma técnica do produto_na_pagina</a:t>
             </a:r>
           </a:p>
           <a:p>
             <a:pPr algn="l">
               <a:spcAft>
-                <a:spcPts val="600"/>
+                <a:spcPts val="500"/>
               </a:spcAft>
             </a:pPr>
             <a:r>
-              <a:rPr sz="1800" b="0" i="0">
+              <a:rPr sz="1700" b="0">
                 <a:solidFill>
                   <a:srgbClr val="B8E0D8"/>
                 </a:solidFill>
                 <a:latin typeface="Consolas"/>
               </a:rPr>
-              <a:t>    # 2) ordena por (pedidos, similaridade)</a:t>
+              <a:t># passo 2  ordenar por pedidos (+ “juntos” nas cestas)</a:t>
             </a:r>
           </a:p>
           <a:p>
             <a:pPr algn="l">
               <a:spcAft>
-                <a:spcPts val="600"/>
+                <a:spcPts val="500"/>
               </a:spcAft>
             </a:pPr>
             <a:r>
-              <a:rPr sz="1800" b="0" i="0">
+              <a:rPr sz="1700" b="0">
                 <a:solidFill>
                   <a:srgbClr val="B8E0D8"/>
                 </a:solidFill>
                 <a:latin typeface="Consolas"/>
               </a:rPr>
-              <a:t>    # 3) se len &lt; limite → completa com populares</a:t>
+              <a:t># passo 3  se ainda faltar vaga → pegar os mais pedidos</a:t>
             </a:r>
           </a:p>
           <a:p>
             <a:pPr algn="l">
               <a:spcAft>
-                <a:spcPts val="600"/>
+                <a:spcPts val="500"/>
               </a:spcAft>
             </a:pPr>
             <a:r>
-              <a:rPr sz="1800" b="0" i="0">
+              <a:rPr sz="1700" b="0">
                 <a:solidFill>
                   <a:srgbClr val="B8E0D8"/>
                 </a:solidFill>
                 <a:latin typeface="Consolas"/>
               </a:rPr>
-              <a:t>    # 4) score = 0.7*pop_n + 0.3*sim   (ou 0.5*pop_n)</a:t>
+              <a:t># passo 4  montar items[] com nome, score, reason, rank</a:t>
             </a:r>
           </a:p>
           <a:p>
             <a:pPr algn="l">
               <a:spcAft>
-                <a:spcPts val="600"/>
+                <a:spcPts val="500"/>
               </a:spcAft>
             </a:pPr>
             <a:r>
-              <a:rPr sz="1800" b="0" i="0">
+              <a:rPr sz="1700" b="0">
                 <a:solidFill>
                   <a:srgbClr val="B8E0D8"/>
                 </a:solidFill>
                 <a:latin typeface="Consolas"/>
               </a:rPr>
-              <a:t>    return {"items": [...], "fallback_used": ...}</a:t>
+              <a:t/>
+            </a:r>
+          </a:p>
+          <a:p>
+            <a:pPr algn="l">
+              <a:spcAft>
+                <a:spcPts val="500"/>
+              </a:spcAft>
+            </a:pPr>
+            <a:r>
+              <a:rPr sz="1700" b="0">
+                <a:solidFill>
+                  <a:srgbClr val="B8E0D8"/>
+                </a:solidFill>
+                <a:latin typeface="Consolas"/>
+              </a:rPr>
+              <a:t># treino.py — roda antes, uma vez</a:t>
+            </a:r>
+          </a:p>
+          <a:p>
+            <a:pPr algn="l">
+              <a:spcAft>
+                <a:spcPts val="500"/>
+              </a:spcAft>
+            </a:pPr>
+            <a:r>
+              <a:rPr sz="1700" b="0">
+                <a:solidFill>
+                  <a:srgbClr val="B8E0D8"/>
+                </a:solidFill>
+                <a:latin typeface="Consolas"/>
+              </a:rPr>
+              <a:t># lê catalogo.json  →  grava popularidade e similaridade</a:t>
             </a:r>
           </a:p>
         </p:txBody>
@@ -5252,79 +5897,8 @@
         </p:nvSpPr>
         <p:spPr>
           <a:xfrm>
-            <a:off x="640080" y="4572000"/>
-            <a:ext cx="10972800" cy="1280160"/>
-          </a:xfrm>
-          <a:prstGeom prst="rect">
-            <a:avLst/>
-          </a:prstGeom>
-          <a:noFill/>
-        </p:spPr>
-        <p:txBody>
-          <a:bodyPr wrap="square" lIns="50800" rIns="50800" tIns="25400" bIns="25400">
-            <a:spAutoFit/>
-          </a:bodyPr>
-          <a:lstStyle/>
-          <a:p>
-            <a:pPr algn="l">
-              <a:spcAft>
-                <a:spcPts val="400"/>
-              </a:spcAft>
-            </a:pPr>
-            <a:r>
-              <a:rPr sz="1600" b="0" i="0">
-                <a:solidFill>
-                  <a:srgbClr val="C5D0CE"/>
-                </a:solidFill>
-                <a:latin typeface="Calibri"/>
-              </a:rPr>
-              <a:t>treino.py grava o dicionário (produtos, popularidade, similaridade) no store.</a:t>
-            </a:r>
-          </a:p>
-          <a:p>
-            <a:pPr algn="l">
-              <a:spcAft>
-                <a:spcPts val="400"/>
-              </a:spcAft>
-            </a:pPr>
-            <a:r>
-              <a:rPr sz="1600" b="0" i="0">
-                <a:solidFill>
-                  <a:srgbClr val="C5D0CE"/>
-                </a:solidFill>
-                <a:latin typeface="Calibri"/>
-              </a:rPr>
-              <a:t>service.py só carrega o pickle e aplica a regra — fácil de trocar depois</a:t>
-            </a:r>
-          </a:p>
-          <a:p>
-            <a:pPr algn="l">
-              <a:spcAft>
-                <a:spcPts val="400"/>
-              </a:spcAft>
-            </a:pPr>
-            <a:r>
-              <a:rPr sz="1600" b="0" i="0">
-                <a:solidFill>
-                  <a:srgbClr val="C5D0CE"/>
-                </a:solidFill>
-                <a:latin typeface="Calibri"/>
-              </a:rPr>
-              <a:t>por um modelo treinado sem mudar o contrato HTTP.</a:t>
-            </a:r>
-          </a:p>
-        </p:txBody>
-      </p:sp>
-      <p:sp>
-        <p:nvSpPr>
-          <p:cNvPr id="7" name="TextBox 6"/>
-          <p:cNvSpPr txBox="1"/>
-          <p:nvPr/>
-        </p:nvSpPr>
-        <p:spPr>
-          <a:xfrm>
-            <a:off x="640080" y="6126480"/>
-            <a:ext cx="10972800" cy="365760"/>
+            <a:off x="548640" y="6126480"/>
+            <a:ext cx="10972800" cy="320040"/>
           </a:xfrm>
           <a:prstGeom prst="rect">
             <a:avLst/>
@@ -5343,13 +5917,13 @@
               </a:spcAft>
             </a:pPr>
             <a:r>
-              <a:rPr sz="1200" b="0" i="0">
+              <a:rPr sz="1200" b="0">
                 <a:solidFill>
                   <a:srgbClr val="4A5558"/>
                 </a:solidFill>
                 <a:latin typeface="Calibri"/>
               </a:rPr>
-              <a:t>4 / 5  ·  código</a:t>
+              <a:t>4 / 5</a:t>
             </a:r>
           </a:p>
         </p:txBody>
@@ -5423,7 +5997,7 @@
         </p:nvSpPr>
         <p:spPr>
           <a:xfrm>
-            <a:off x="640080" y="228600"/>
+            <a:off x="548640" y="228600"/>
             <a:ext cx="10972800" cy="457200"/>
           </a:xfrm>
           <a:prstGeom prst="rect">
@@ -5443,13 +6017,13 @@
               </a:spcAft>
             </a:pPr>
             <a:r>
-              <a:rPr sz="2800" b="1" i="0">
+              <a:rPr sz="2400" b="1">
                 <a:solidFill>
                   <a:srgbClr val="1A1A1A"/>
                 </a:solidFill>
                 <a:latin typeface="Georgia"/>
               </a:rPr>
-              <a:t>Onde isso entra no mapa da IA</a:t>
+              <a:t>Onde isso fica no mapa da Inteligência Artificial</a:t>
             </a:r>
           </a:p>
         </p:txBody>
@@ -5462,8 +6036,8 @@
         </p:nvSpPr>
         <p:spPr>
           <a:xfrm>
-            <a:off x="502920" y="1051560"/>
-            <a:ext cx="3383280" cy="2377440"/>
+            <a:off x="457200" y="1005840"/>
+            <a:ext cx="3383280" cy="2468880"/>
           </a:xfrm>
           <a:prstGeom prst="roundRect">
             <a:avLst/>
@@ -5496,49 +6070,49 @@
           <a:p>
             <a:pPr algn="ctr"/>
             <a:r>
-              <a:rPr sz="1800" b="1" i="0">
+              <a:rPr sz="1800" b="1">
                 <a:solidFill>
                   <a:srgbClr val="FFFFFF"/>
                 </a:solidFill>
                 <a:latin typeface="Calibri"/>
               </a:rPr>
-              <a:t>IA simbólica</a:t>
+              <a:t>Regras</a:t>
             </a:r>
           </a:p>
           <a:p>
             <a:pPr algn="ctr"/>
             <a:r>
-              <a:rPr sz="1800" b="1" i="0">
+              <a:rPr sz="1800" b="1">
                 <a:solidFill>
                   <a:srgbClr val="FFFFFF"/>
                 </a:solidFill>
                 <a:latin typeface="Calibri"/>
               </a:rPr>
-              <a:t>/ regras</a:t>
+              <a:t>explícitas</a:t>
             </a:r>
           </a:p>
           <a:p>
             <a:pPr algn="ctr"/>
             <a:r>
-              <a:rPr sz="1300" b="0" i="0">
+              <a:rPr sz="1300" b="0">
                 <a:solidFill>
                   <a:srgbClr val="FFFFFF"/>
                 </a:solidFill>
                 <a:latin typeface="Calibri"/>
               </a:rPr>
-              <a:t>Nosso baseline</a:t>
+              <a:t>Hoje: mesma técnica</a:t>
             </a:r>
           </a:p>
           <a:p>
             <a:pPr algn="ctr"/>
             <a:r>
-              <a:rPr sz="1300" b="0" i="0">
+              <a:rPr sz="1300" b="0">
                 <a:solidFill>
                   <a:srgbClr val="FFFFFF"/>
                 </a:solidFill>
                 <a:latin typeface="Calibri"/>
               </a:rPr>
-              <a:t>vive aqui hoje</a:t>
+              <a:t>+ mais pedidos</a:t>
             </a:r>
           </a:p>
         </p:txBody>
@@ -5551,8 +6125,8 @@
         </p:nvSpPr>
         <p:spPr>
           <a:xfrm>
-            <a:off x="4297680" y="1051560"/>
-            <a:ext cx="3383280" cy="2377440"/>
+            <a:off x="4297680" y="1005840"/>
+            <a:ext cx="3383280" cy="2468880"/>
           </a:xfrm>
           <a:prstGeom prst="roundRect">
             <a:avLst/>
@@ -5585,7 +6159,7 @@
           <a:p>
             <a:pPr algn="ctr"/>
             <a:r>
-              <a:rPr sz="1800" b="1" i="0">
+              <a:rPr sz="1800" b="1">
                 <a:solidFill>
                   <a:srgbClr val="FFFFFF"/>
                 </a:solidFill>
@@ -5597,7 +6171,7 @@
           <a:p>
             <a:pPr algn="ctr"/>
             <a:r>
-              <a:rPr sz="1800" b="1" i="0">
+              <a:rPr sz="1800" b="1">
                 <a:solidFill>
                   <a:srgbClr val="FFFFFF"/>
                 </a:solidFill>
@@ -5609,37 +6183,37 @@
           <a:p>
             <a:pPr algn="ctr"/>
             <a:r>
-              <a:rPr sz="1300" b="0" i="0">
+              <a:rPr sz="1300" b="0">
                 <a:solidFill>
                   <a:srgbClr val="FFFFFF"/>
                 </a:solidFill>
                 <a:latin typeface="Calibri"/>
               </a:rPr>
-              <a:t>Supervisionado,</a:t>
+              <a:t>O computador ajusta</a:t>
             </a:r>
           </a:p>
           <a:p>
             <a:pPr algn="ctr"/>
             <a:r>
-              <a:rPr sz="1300" b="0" i="0">
+              <a:rPr sz="1300" b="0">
                 <a:solidFill>
                   <a:srgbClr val="FFFFFF"/>
                 </a:solidFill>
                 <a:latin typeface="Calibri"/>
               </a:rPr>
-              <a:t>não supervisionado,</a:t>
+              <a:t>parâmetros com dados</a:t>
             </a:r>
           </a:p>
           <a:p>
             <a:pPr algn="ctr"/>
             <a:r>
-              <a:rPr sz="1300" b="0" i="0">
+              <a:rPr sz="1300" b="0">
                 <a:solidFill>
                   <a:srgbClr val="FFFFFF"/>
                 </a:solidFill>
                 <a:latin typeface="Calibri"/>
               </a:rPr>
-              <a:t>por reforço</a:t>
+              <a:t>e métricas</a:t>
             </a:r>
           </a:p>
         </p:txBody>
@@ -5652,8 +6226,8 @@
         </p:nvSpPr>
         <p:spPr>
           <a:xfrm>
-            <a:off x="8092440" y="1051560"/>
-            <a:ext cx="3383280" cy="2377440"/>
+            <a:off x="8138160" y="1005840"/>
+            <a:ext cx="3383280" cy="2468880"/>
           </a:xfrm>
           <a:prstGeom prst="roundRect">
             <a:avLst/>
@@ -5661,8 +6235,10 @@
           <a:solidFill>
             <a:srgbClr val="E8F2F0"/>
           </a:solidFill>
-          <a:ln>
-            <a:noFill/>
+          <a:ln w="15875">
+            <a:solidFill>
+              <a:srgbClr val="0D7A6F"/>
+            </a:solidFill>
           </a:ln>
           <a:effectLst/>
         </p:spPr>
@@ -5686,7 +6262,7 @@
           <a:p>
             <a:pPr algn="ctr"/>
             <a:r>
-              <a:rPr sz="1800" b="1" i="0">
+              <a:rPr sz="1800" b="1">
                 <a:solidFill>
                   <a:srgbClr val="1A1A1A"/>
                 </a:solidFill>
@@ -5698,49 +6274,25 @@
           <a:p>
             <a:pPr algn="ctr"/>
             <a:r>
-              <a:rPr sz="1800" b="1" i="0">
+              <a:rPr sz="1300" b="0">
                 <a:solidFill>
                   <a:srgbClr val="1A1A1A"/>
                 </a:solidFill>
                 <a:latin typeface="Calibri"/>
               </a:rPr>
-              <a:t>/ LLMs</a:t>
+              <a:t>Texto, imagens,</a:t>
             </a:r>
           </a:p>
           <a:p>
             <a:pPr algn="ctr"/>
             <a:r>
-              <a:rPr sz="1300" b="0" i="0">
+              <a:rPr sz="1300" b="0">
                 <a:solidFill>
                   <a:srgbClr val="1A1A1A"/>
                 </a:solidFill>
                 <a:latin typeface="Calibri"/>
               </a:rPr>
-              <a:t>Texto, código,</a:t>
-            </a:r>
-          </a:p>
-          <a:p>
-            <a:pPr algn="ctr"/>
-            <a:r>
-              <a:rPr sz="1300" b="0" i="0">
-                <a:solidFill>
-                  <a:srgbClr val="1A1A1A"/>
-                </a:solidFill>
-                <a:latin typeface="Calibri"/>
-              </a:rPr>
-              <a:t>agentes — outro</a:t>
-            </a:r>
-          </a:p>
-          <a:p>
-            <a:pPr algn="ctr"/>
-            <a:r>
-              <a:rPr sz="1300" b="0" i="0">
-                <a:solidFill>
-                  <a:srgbClr val="1A1A1A"/>
-                </a:solidFill>
-                <a:latin typeface="Calibri"/>
-              </a:rPr>
-              <a:t>canto do mapa</a:t>
+              <a:t>agentes conversando</a:t>
             </a:r>
           </a:p>
         </p:txBody>
@@ -5753,8 +6305,8 @@
         </p:nvSpPr>
         <p:spPr>
           <a:xfrm>
-            <a:off x="640080" y="3749039"/>
-            <a:ext cx="10972800" cy="2103120"/>
+            <a:off x="548640" y="3840480"/>
+            <a:ext cx="11064240" cy="2011680"/>
           </a:xfrm>
           <a:prstGeom prst="rect">
             <a:avLst/>
@@ -5773,13 +6325,13 @@
               </a:spcAft>
             </a:pPr>
             <a:r>
-              <a:rPr sz="1600" b="0" i="0">
+              <a:rPr sz="1600" b="0">
                 <a:solidFill>
                   <a:srgbClr val="1A1A1A"/>
                 </a:solidFill>
                 <a:latin typeface="Calibri"/>
               </a:rPr>
-              <a:t>Recomendação “de verdade” no AM costuma ser: conteúdo, colaborativa,</a:t>
+              <a:t>Os três campos se misturam em produtos reais. Nesta aula ficamos no</a:t>
             </a:r>
           </a:p>
           <a:p>
@@ -5789,13 +6341,13 @@
               </a:spcAft>
             </a:pPr>
             <a:r>
-              <a:rPr sz="1600" b="0" i="0">
+              <a:rPr sz="1600" b="0">
                 <a:solidFill>
                   <a:srgbClr val="1A1A1A"/>
                 </a:solidFill>
                 <a:latin typeface="Calibri"/>
               </a:rPr>
-              <a:t>ou híbrida — com dados de interação e métricas (precisão@k, recall@k).</a:t>
+              <a:t>primeiro: uma regra clara, testável, servida por HTTP.</a:t>
             </a:r>
           </a:p>
           <a:p>
@@ -5805,7 +6357,7 @@
               </a:spcAft>
             </a:pPr>
             <a:r>
-              <a:rPr sz="1600" b="0" i="0">
+              <a:rPr sz="1600" b="0">
                 <a:solidFill>
                   <a:srgbClr val="1A1A1A"/>
                 </a:solidFill>
@@ -5821,13 +6373,13 @@
               </a:spcAft>
             </a:pPr>
             <a:r>
-              <a:rPr sz="1600" b="0" i="0">
+              <a:rPr sz="1600" b="0">
                 <a:solidFill>
                   <a:srgbClr val="1A1A1A"/>
                 </a:solidFill>
                 <a:latin typeface="Calibri"/>
               </a:rPr>
-              <a:t>Próximo passo de estudo (módulo Microsoft Learn, pt-BR): fundamentos</a:t>
+              <a:t>Depois: (1) ligar à vitrine do marketplace · (2) estudar fundamentos</a:t>
             </a:r>
           </a:p>
           <a:p>
@@ -5837,13 +6389,13 @@
               </a:spcAft>
             </a:pPr>
             <a:r>
-              <a:rPr sz="1600" b="0" i="0">
+              <a:rPr sz="1600" b="0">
                 <a:solidFill>
                   <a:srgbClr val="1A1A1A"/>
                 </a:solidFill>
                 <a:latin typeface="Calibri"/>
               </a:rPr>
-              <a:t>de AM para evoluir esta regra até um modelo treinado — mantendo o BentoML.</a:t>
+              <a:t>de aprendizado de máquina (Microsoft Learn, pt-BR) para trocar a regra</a:t>
             </a:r>
           </a:p>
           <a:p>
@@ -5853,13 +6405,13 @@
               </a:spcAft>
             </a:pPr>
             <a:r>
-              <a:rPr sz="1600" b="0" i="0">
+              <a:rPr sz="1600" b="0">
                 <a:solidFill>
                   <a:srgbClr val="1A1A1A"/>
                 </a:solidFill>
                 <a:latin typeface="Calibri"/>
               </a:rPr>
-              <a:t>Antes disso: ligar esta API à vitrine do marketplace da primeira aula.</a:t>
+              <a:t>por um modelo treinado — sem mudar o contrato da API.</a:t>
             </a:r>
           </a:p>
         </p:txBody>
@@ -5872,8 +6424,8 @@
         </p:nvSpPr>
         <p:spPr>
           <a:xfrm>
-            <a:off x="640080" y="6126480"/>
-            <a:ext cx="10972800" cy="365760"/>
+            <a:off x="548640" y="6126480"/>
+            <a:ext cx="10972800" cy="320040"/>
           </a:xfrm>
           <a:prstGeom prst="rect">
             <a:avLst/>
@@ -5892,13 +6444,13 @@
               </a:spcAft>
             </a:pPr>
             <a:r>
-              <a:rPr sz="1200" b="0" i="0">
+              <a:rPr sz="1200" b="0">
                 <a:solidFill>
                   <a:srgbClr val="4A5558"/>
                 </a:solidFill>
                 <a:latin typeface="Calibri"/>
               </a:rPr>
-              <a:t>5 / 5  ·  mapa IA / AM</a:t>
+              <a:t>5 / 5</a:t>
             </a:r>
           </a:p>
         </p:txBody>

</xml_diff>

<commit_message>
feat: slide sobre treino.py entre o fluxo e o exemplo
<p>Insere o passo Lê→Calcula→Empacota→Grava e renumeração do deck para 6 slides.</p>

Co-authored-by: Cursor <cursoragent@cursor.com>
</commit_message>
<xml_diff>
--- a/slides/recomendador-bentoml.pptx
+++ b/slides/recomendador-bentoml.pptx
@@ -10,6 +10,7 @@
     <p:sldId id="258" r:id="rId9"/>
     <p:sldId id="259" r:id="rId10"/>
     <p:sldId id="260" r:id="rId11"/>
+    <p:sldId id="261" r:id="rId12"/>
   </p:sldIdLst>
   <p:sldSz cx="12191695" cy="6858000" type="screen4x3"/>
   <p:notesSz cx="6858000" cy="9144000"/>
@@ -3557,7 +3558,7 @@
                 </a:solidFill>
                 <a:latin typeface="Calibri"/>
               </a:rPr>
-              <a:t>1 / 5</a:t>
+              <a:t>1 / 6</a:t>
             </a:r>
           </a:p>
         </p:txBody>
@@ -4955,7 +4956,7 @@
                 </a:solidFill>
                 <a:latin typeface="Calibri"/>
               </a:rPr>
-              <a:t>2 / 5</a:t>
+              <a:t>2 / 6</a:t>
             </a:r>
           </a:p>
         </p:txBody>
@@ -5049,13 +5050,13 @@
               </a:spcAft>
             </a:pPr>
             <a:r>
-              <a:rPr sz="2600" b="1">
+              <a:rPr sz="3000" b="1">
                 <a:solidFill>
                   <a:srgbClr val="1A1A1A"/>
                 </a:solidFill>
                 <a:latin typeface="Georgia"/>
               </a:rPr>
-              <a:t>Exemplo: cliente abriu o Jarro de barro</a:t>
+              <a:t>O que treino.py faz</a:t>
             </a:r>
           </a:p>
         </p:txBody>
@@ -5068,7 +5069,7 @@
         </p:nvSpPr>
         <p:spPr>
           <a:xfrm>
-            <a:off x="502920" y="731520"/>
+            <a:off x="502920" y="777240"/>
             <a:ext cx="11155680" cy="365760"/>
           </a:xfrm>
           <a:prstGeom prst="rect">
@@ -5088,13 +5089,13 @@
               </a:spcAft>
             </a:pPr>
             <a:r>
-              <a:rPr sz="1500" b="0">
+              <a:rPr sz="1600" b="0">
                 <a:solidFill>
                   <a:srgbClr val="4A5558"/>
                 </a:solidFill>
                 <a:latin typeface="Calibri"/>
               </a:rPr>
-              <a:t>produto_na_pagina = p01 · técnica = cerâmica · pedimos 4 sugestões</a:t>
+              <a:t>Roda uma vez antes de servir. Prepara números que o service.py só consulta.</a:t>
             </a:r>
           </a:p>
         </p:txBody>
@@ -5107,8 +5108,580 @@
         </p:nvSpPr>
         <p:spPr>
           <a:xfrm>
-            <a:off x="457200" y="1234440"/>
-            <a:ext cx="5669280" cy="4480560"/>
+            <a:off x="502920" y="1417320"/>
+            <a:ext cx="2606040" cy="1828800"/>
+          </a:xfrm>
+          <a:prstGeom prst="roundRect">
+            <a:avLst/>
+          </a:prstGeom>
+          <a:solidFill>
+            <a:srgbClr val="0D7A6F"/>
+          </a:solidFill>
+          <a:ln>
+            <a:noFill/>
+          </a:ln>
+          <a:effectLst/>
+        </p:spPr>
+        <p:style>
+          <a:lnRef idx="1">
+            <a:schemeClr val="accent1"/>
+          </a:lnRef>
+          <a:fillRef idx="3">
+            <a:schemeClr val="accent1"/>
+          </a:fillRef>
+          <a:effectRef idx="2">
+            <a:schemeClr val="accent1"/>
+          </a:effectRef>
+          <a:fontRef idx="minor">
+            <a:schemeClr val="lt1"/>
+          </a:fontRef>
+        </p:style>
+        <p:txBody>
+          <a:bodyPr rtlCol="0" anchor="ctr"/>
+          <a:lstStyle/>
+          <a:p>
+            <a:pPr algn="ctr"/>
+            <a:r>
+              <a:rPr sz="2000" b="1">
+                <a:solidFill>
+                  <a:srgbClr val="FFFFFF"/>
+                </a:solidFill>
+                <a:latin typeface="Calibri"/>
+              </a:rPr>
+              <a:t>Lê</a:t>
+            </a:r>
+          </a:p>
+          <a:p>
+            <a:pPr algn="ctr"/>
+            <a:r>
+              <a:rPr sz="1300" b="0">
+                <a:solidFill>
+                  <a:srgbClr val="FFFFFF"/>
+                </a:solidFill>
+                <a:latin typeface="Calibri"/>
+              </a:rPr>
+              <a:t>dados/catalogo.json</a:t>
+            </a:r>
+          </a:p>
+          <a:p>
+            <a:pPr algn="ctr"/>
+            <a:r>
+              <a:rPr sz="1300" b="0">
+                <a:solidFill>
+                  <a:srgbClr val="FFFFFF"/>
+                </a:solidFill>
+                <a:latin typeface="Calibri"/>
+              </a:rPr>
+              <a:t>produtos + cestas</a:t>
+            </a:r>
+          </a:p>
+        </p:txBody>
+      </p:sp>
+      <p:sp>
+        <p:nvSpPr>
+          <p:cNvPr id="6" name="Rectangle 5"/>
+          <p:cNvSpPr/>
+          <p:nvPr/>
+        </p:nvSpPr>
+        <p:spPr>
+          <a:xfrm>
+            <a:off x="3108960" y="2311720"/>
+            <a:ext cx="118872" cy="40000"/>
+          </a:xfrm>
+          <a:prstGeom prst="rect">
+            <a:avLst/>
+          </a:prstGeom>
+          <a:solidFill>
+            <a:srgbClr val="0D7A6F"/>
+          </a:solidFill>
+          <a:ln>
+            <a:noFill/>
+          </a:ln>
+          <a:effectLst/>
+        </p:spPr>
+        <p:style>
+          <a:lnRef idx="1">
+            <a:schemeClr val="accent1"/>
+          </a:lnRef>
+          <a:fillRef idx="3">
+            <a:schemeClr val="accent1"/>
+          </a:fillRef>
+          <a:effectRef idx="2">
+            <a:schemeClr val="accent1"/>
+          </a:effectRef>
+          <a:fontRef idx="minor">
+            <a:schemeClr val="lt1"/>
+          </a:fontRef>
+        </p:style>
+        <p:txBody>
+          <a:bodyPr rtlCol="0" anchor="ctr"/>
+          <a:lstStyle/>
+          <a:p>
+            <a:pPr algn="ctr"/>
+          </a:p>
+        </p:txBody>
+      </p:sp>
+      <p:sp>
+        <p:nvSpPr>
+          <p:cNvPr id="7" name="Right Arrow 6"/>
+          <p:cNvSpPr/>
+          <p:nvPr/>
+        </p:nvSpPr>
+        <p:spPr>
+          <a:xfrm>
+            <a:off x="3136392" y="2221992"/>
+            <a:ext cx="256032" cy="219456"/>
+          </a:xfrm>
+          <a:prstGeom prst="rightArrow">
+            <a:avLst/>
+          </a:prstGeom>
+          <a:solidFill>
+            <a:srgbClr val="0D7A6F"/>
+          </a:solidFill>
+          <a:ln>
+            <a:noFill/>
+          </a:ln>
+          <a:effectLst/>
+        </p:spPr>
+        <p:style>
+          <a:lnRef idx="1">
+            <a:schemeClr val="accent1"/>
+          </a:lnRef>
+          <a:fillRef idx="3">
+            <a:schemeClr val="accent1"/>
+          </a:fillRef>
+          <a:effectRef idx="2">
+            <a:schemeClr val="accent1"/>
+          </a:effectRef>
+          <a:fontRef idx="minor">
+            <a:schemeClr val="lt1"/>
+          </a:fontRef>
+        </p:style>
+        <p:txBody>
+          <a:bodyPr rtlCol="0" anchor="ctr"/>
+          <a:lstStyle/>
+          <a:p>
+            <a:pPr algn="ctr"/>
+          </a:p>
+        </p:txBody>
+      </p:sp>
+      <p:sp>
+        <p:nvSpPr>
+          <p:cNvPr id="8" name="Rounded Rectangle 7"/>
+          <p:cNvSpPr/>
+          <p:nvPr/>
+        </p:nvSpPr>
+        <p:spPr>
+          <a:xfrm>
+            <a:off x="3337560" y="1417320"/>
+            <a:ext cx="2606040" cy="1828800"/>
+          </a:xfrm>
+          <a:prstGeom prst="roundRect">
+            <a:avLst/>
+          </a:prstGeom>
+          <a:solidFill>
+            <a:srgbClr val="1E2A2E"/>
+          </a:solidFill>
+          <a:ln>
+            <a:noFill/>
+          </a:ln>
+          <a:effectLst/>
+        </p:spPr>
+        <p:style>
+          <a:lnRef idx="1">
+            <a:schemeClr val="accent1"/>
+          </a:lnRef>
+          <a:fillRef idx="3">
+            <a:schemeClr val="accent1"/>
+          </a:fillRef>
+          <a:effectRef idx="2">
+            <a:schemeClr val="accent1"/>
+          </a:effectRef>
+          <a:fontRef idx="minor">
+            <a:schemeClr val="lt1"/>
+          </a:fontRef>
+        </p:style>
+        <p:txBody>
+          <a:bodyPr rtlCol="0" anchor="ctr"/>
+          <a:lstStyle/>
+          <a:p>
+            <a:pPr algn="ctr"/>
+            <a:r>
+              <a:rPr sz="2000" b="1">
+                <a:solidFill>
+                  <a:srgbClr val="FFFFFF"/>
+                </a:solidFill>
+                <a:latin typeface="Calibri"/>
+              </a:rPr>
+              <a:t>Calcula</a:t>
+            </a:r>
+          </a:p>
+          <a:p>
+            <a:pPr algn="ctr"/>
+            <a:r>
+              <a:rPr sz="1300" b="0">
+                <a:solidFill>
+                  <a:srgbClr val="FFFFFF"/>
+                </a:solidFill>
+                <a:latin typeface="Calibri"/>
+              </a:rPr>
+              <a:t>pedidos ÷ máximo</a:t>
+            </a:r>
+          </a:p>
+          <a:p>
+            <a:pPr algn="ctr"/>
+            <a:r>
+              <a:rPr sz="1300" b="0">
+                <a:solidFill>
+                  <a:srgbClr val="FFFFFF"/>
+                </a:solidFill>
+                <a:latin typeface="Calibri"/>
+              </a:rPr>
+              <a:t>e “juntos” nas cestas</a:t>
+            </a:r>
+          </a:p>
+        </p:txBody>
+      </p:sp>
+      <p:sp>
+        <p:nvSpPr>
+          <p:cNvPr id="9" name="Rectangle 8"/>
+          <p:cNvSpPr/>
+          <p:nvPr/>
+        </p:nvSpPr>
+        <p:spPr>
+          <a:xfrm>
+            <a:off x="5943600" y="2311720"/>
+            <a:ext cx="118872" cy="40000"/>
+          </a:xfrm>
+          <a:prstGeom prst="rect">
+            <a:avLst/>
+          </a:prstGeom>
+          <a:solidFill>
+            <a:srgbClr val="0D7A6F"/>
+          </a:solidFill>
+          <a:ln>
+            <a:noFill/>
+          </a:ln>
+          <a:effectLst/>
+        </p:spPr>
+        <p:style>
+          <a:lnRef idx="1">
+            <a:schemeClr val="accent1"/>
+          </a:lnRef>
+          <a:fillRef idx="3">
+            <a:schemeClr val="accent1"/>
+          </a:fillRef>
+          <a:effectRef idx="2">
+            <a:schemeClr val="accent1"/>
+          </a:effectRef>
+          <a:fontRef idx="minor">
+            <a:schemeClr val="lt1"/>
+          </a:fontRef>
+        </p:style>
+        <p:txBody>
+          <a:bodyPr rtlCol="0" anchor="ctr"/>
+          <a:lstStyle/>
+          <a:p>
+            <a:pPr algn="ctr"/>
+          </a:p>
+        </p:txBody>
+      </p:sp>
+      <p:sp>
+        <p:nvSpPr>
+          <p:cNvPr id="10" name="Right Arrow 9"/>
+          <p:cNvSpPr/>
+          <p:nvPr/>
+        </p:nvSpPr>
+        <p:spPr>
+          <a:xfrm>
+            <a:off x="5971032" y="2221992"/>
+            <a:ext cx="256032" cy="219456"/>
+          </a:xfrm>
+          <a:prstGeom prst="rightArrow">
+            <a:avLst/>
+          </a:prstGeom>
+          <a:solidFill>
+            <a:srgbClr val="0D7A6F"/>
+          </a:solidFill>
+          <a:ln>
+            <a:noFill/>
+          </a:ln>
+          <a:effectLst/>
+        </p:spPr>
+        <p:style>
+          <a:lnRef idx="1">
+            <a:schemeClr val="accent1"/>
+          </a:lnRef>
+          <a:fillRef idx="3">
+            <a:schemeClr val="accent1"/>
+          </a:fillRef>
+          <a:effectRef idx="2">
+            <a:schemeClr val="accent1"/>
+          </a:effectRef>
+          <a:fontRef idx="minor">
+            <a:schemeClr val="lt1"/>
+          </a:fontRef>
+        </p:style>
+        <p:txBody>
+          <a:bodyPr rtlCol="0" anchor="ctr"/>
+          <a:lstStyle/>
+          <a:p>
+            <a:pPr algn="ctr"/>
+          </a:p>
+        </p:txBody>
+      </p:sp>
+      <p:sp>
+        <p:nvSpPr>
+          <p:cNvPr id="11" name="Rounded Rectangle 10"/>
+          <p:cNvSpPr/>
+          <p:nvPr/>
+        </p:nvSpPr>
+        <p:spPr>
+          <a:xfrm>
+            <a:off x="6172200" y="1417320"/>
+            <a:ext cx="2606040" cy="1828800"/>
+          </a:xfrm>
+          <a:prstGeom prst="roundRect">
+            <a:avLst/>
+          </a:prstGeom>
+          <a:solidFill>
+            <a:srgbClr val="0D7A6F"/>
+          </a:solidFill>
+          <a:ln>
+            <a:noFill/>
+          </a:ln>
+          <a:effectLst/>
+        </p:spPr>
+        <p:style>
+          <a:lnRef idx="1">
+            <a:schemeClr val="accent1"/>
+          </a:lnRef>
+          <a:fillRef idx="3">
+            <a:schemeClr val="accent1"/>
+          </a:fillRef>
+          <a:effectRef idx="2">
+            <a:schemeClr val="accent1"/>
+          </a:effectRef>
+          <a:fontRef idx="minor">
+            <a:schemeClr val="lt1"/>
+          </a:fontRef>
+        </p:style>
+        <p:txBody>
+          <a:bodyPr rtlCol="0" anchor="ctr"/>
+          <a:lstStyle/>
+          <a:p>
+            <a:pPr algn="ctr"/>
+            <a:r>
+              <a:rPr sz="2000" b="1">
+                <a:solidFill>
+                  <a:srgbClr val="FFFFFF"/>
+                </a:solidFill>
+                <a:latin typeface="Calibri"/>
+              </a:rPr>
+              <a:t>Empacota</a:t>
+            </a:r>
+          </a:p>
+          <a:p>
+            <a:pPr algn="ctr"/>
+            <a:r>
+              <a:rPr sz="1300" b="0">
+                <a:solidFill>
+                  <a:srgbClr val="FFFFFF"/>
+                </a:solidFill>
+                <a:latin typeface="Calibri"/>
+              </a:rPr>
+              <a:t>um dicionário</a:t>
+            </a:r>
+          </a:p>
+          <a:p>
+            <a:pPr algn="ctr"/>
+            <a:r>
+              <a:rPr sz="1300" b="0">
+                <a:solidFill>
+                  <a:srgbClr val="FFFFFF"/>
+                </a:solidFill>
+                <a:latin typeface="Calibri"/>
+              </a:rPr>
+              <a:t>Python</a:t>
+            </a:r>
+          </a:p>
+        </p:txBody>
+      </p:sp>
+      <p:sp>
+        <p:nvSpPr>
+          <p:cNvPr id="12" name="Rectangle 11"/>
+          <p:cNvSpPr/>
+          <p:nvPr/>
+        </p:nvSpPr>
+        <p:spPr>
+          <a:xfrm>
+            <a:off x="8778240" y="2311720"/>
+            <a:ext cx="118872" cy="40000"/>
+          </a:xfrm>
+          <a:prstGeom prst="rect">
+            <a:avLst/>
+          </a:prstGeom>
+          <a:solidFill>
+            <a:srgbClr val="0D7A6F"/>
+          </a:solidFill>
+          <a:ln>
+            <a:noFill/>
+          </a:ln>
+          <a:effectLst/>
+        </p:spPr>
+        <p:style>
+          <a:lnRef idx="1">
+            <a:schemeClr val="accent1"/>
+          </a:lnRef>
+          <a:fillRef idx="3">
+            <a:schemeClr val="accent1"/>
+          </a:fillRef>
+          <a:effectRef idx="2">
+            <a:schemeClr val="accent1"/>
+          </a:effectRef>
+          <a:fontRef idx="minor">
+            <a:schemeClr val="lt1"/>
+          </a:fontRef>
+        </p:style>
+        <p:txBody>
+          <a:bodyPr rtlCol="0" anchor="ctr"/>
+          <a:lstStyle/>
+          <a:p>
+            <a:pPr algn="ctr"/>
+          </a:p>
+        </p:txBody>
+      </p:sp>
+      <p:sp>
+        <p:nvSpPr>
+          <p:cNvPr id="13" name="Right Arrow 12"/>
+          <p:cNvSpPr/>
+          <p:nvPr/>
+        </p:nvSpPr>
+        <p:spPr>
+          <a:xfrm>
+            <a:off x="8805672" y="2221992"/>
+            <a:ext cx="256032" cy="219456"/>
+          </a:xfrm>
+          <a:prstGeom prst="rightArrow">
+            <a:avLst/>
+          </a:prstGeom>
+          <a:solidFill>
+            <a:srgbClr val="0D7A6F"/>
+          </a:solidFill>
+          <a:ln>
+            <a:noFill/>
+          </a:ln>
+          <a:effectLst/>
+        </p:spPr>
+        <p:style>
+          <a:lnRef idx="1">
+            <a:schemeClr val="accent1"/>
+          </a:lnRef>
+          <a:fillRef idx="3">
+            <a:schemeClr val="accent1"/>
+          </a:fillRef>
+          <a:effectRef idx="2">
+            <a:schemeClr val="accent1"/>
+          </a:effectRef>
+          <a:fontRef idx="minor">
+            <a:schemeClr val="lt1"/>
+          </a:fontRef>
+        </p:style>
+        <p:txBody>
+          <a:bodyPr rtlCol="0" anchor="ctr"/>
+          <a:lstStyle/>
+          <a:p>
+            <a:pPr algn="ctr"/>
+          </a:p>
+        </p:txBody>
+      </p:sp>
+      <p:sp>
+        <p:nvSpPr>
+          <p:cNvPr id="14" name="Rounded Rectangle 13"/>
+          <p:cNvSpPr/>
+          <p:nvPr/>
+        </p:nvSpPr>
+        <p:spPr>
+          <a:xfrm>
+            <a:off x="9006840" y="1417320"/>
+            <a:ext cx="2606040" cy="1828800"/>
+          </a:xfrm>
+          <a:prstGeom prst="roundRect">
+            <a:avLst/>
+          </a:prstGeom>
+          <a:solidFill>
+            <a:srgbClr val="1E2A2E"/>
+          </a:solidFill>
+          <a:ln>
+            <a:noFill/>
+          </a:ln>
+          <a:effectLst/>
+        </p:spPr>
+        <p:style>
+          <a:lnRef idx="1">
+            <a:schemeClr val="accent1"/>
+          </a:lnRef>
+          <a:fillRef idx="3">
+            <a:schemeClr val="accent1"/>
+          </a:fillRef>
+          <a:effectRef idx="2">
+            <a:schemeClr val="accent1"/>
+          </a:effectRef>
+          <a:fontRef idx="minor">
+            <a:schemeClr val="lt1"/>
+          </a:fontRef>
+        </p:style>
+        <p:txBody>
+          <a:bodyPr rtlCol="0" anchor="ctr"/>
+          <a:lstStyle/>
+          <a:p>
+            <a:pPr algn="ctr"/>
+            <a:r>
+              <a:rPr sz="2000" b="1">
+                <a:solidFill>
+                  <a:srgbClr val="FFFFFF"/>
+                </a:solidFill>
+                <a:latin typeface="Calibri"/>
+              </a:rPr>
+              <a:t>Grava</a:t>
+            </a:r>
+          </a:p>
+          <a:p>
+            <a:pPr algn="ctr"/>
+            <a:r>
+              <a:rPr sz="1300" b="0">
+                <a:solidFill>
+                  <a:srgbClr val="FFFFFF"/>
+                </a:solidFill>
+                <a:latin typeface="Calibri"/>
+              </a:rPr>
+              <a:t>no store BentoML</a:t>
+            </a:r>
+          </a:p>
+          <a:p>
+            <a:pPr algn="ctr"/>
+            <a:r>
+              <a:rPr sz="1300" b="0">
+                <a:solidFill>
+                  <a:srgbClr val="FFFFFF"/>
+                </a:solidFill>
+                <a:latin typeface="Calibri"/>
+              </a:rPr>
+              <a:t>(recomendador:…)</a:t>
+            </a:r>
+          </a:p>
+        </p:txBody>
+      </p:sp>
+      <p:sp>
+        <p:nvSpPr>
+          <p:cNvPr id="15" name="Rounded Rectangle 14"/>
+          <p:cNvSpPr/>
+          <p:nvPr/>
+        </p:nvSpPr>
+        <p:spPr>
+          <a:xfrm>
+            <a:off x="502920" y="3657600"/>
+            <a:ext cx="11155680" cy="2011680"/>
           </a:xfrm>
           <a:prstGeom prst="roundRect">
             <a:avLst/>
@@ -5147,14 +5720,14 @@
       </p:sp>
       <p:sp>
         <p:nvSpPr>
-          <p:cNvPr id="6" name="TextBox 5"/>
+          <p:cNvPr id="16" name="TextBox 15"/>
           <p:cNvSpPr txBox="1"/>
           <p:nvPr/>
         </p:nvSpPr>
         <p:spPr>
           <a:xfrm>
-            <a:off x="640080" y="1371600"/>
-            <a:ext cx="5303520" cy="4206240"/>
+            <a:off x="685800" y="3840480"/>
+            <a:ext cx="10789920" cy="1737360"/>
           </a:xfrm>
           <a:prstGeom prst="rect">
             <a:avLst/>
@@ -5169,379 +5742,72 @@
           <a:p>
             <a:pPr algn="l">
               <a:spcAft>
-                <a:spcPts val="300"/>
+                <a:spcPts val="400"/>
               </a:spcAft>
             </a:pPr>
             <a:r>
-              <a:rPr sz="1500" b="0">
+              <a:rPr sz="1600" b="0">
                 <a:solidFill>
                   <a:srgbClr val="1A1A1A"/>
                 </a:solidFill>
                 <a:latin typeface="Calibri"/>
               </a:rPr>
-              <a:t>1. Outros de cerâmica: Prato, Boneca</a:t>
+              <a:t>Entrada do treino: o JSON do catálogo.</a:t>
             </a:r>
           </a:p>
           <a:p>
             <a:pPr algn="l">
               <a:spcAft>
-                <a:spcPts val="300"/>
+                <a:spcPts val="400"/>
               </a:spcAft>
             </a:pPr>
             <a:r>
-              <a:rPr sz="1500" b="0">
+              <a:rPr sz="1600" b="0">
                 <a:solidFill>
                   <a:srgbClr val="1A1A1A"/>
                 </a:solidFill>
                 <a:latin typeface="Calibri"/>
               </a:rPr>
-              <a:t>   (só 2 — ainda faltam vagas)</a:t>
+              <a:t>Saída do treino: arquivo no model store (popularidade, similaridade, nomes).</a:t>
             </a:r>
           </a:p>
           <a:p>
             <a:pPr algn="l">
               <a:spcAft>
-                <a:spcPts val="300"/>
+                <a:spcPts val="400"/>
               </a:spcAft>
             </a:pPr>
             <a:r>
-              <a:rPr sz="1500" b="0">
+              <a:rPr sz="1600" b="0">
                 <a:solidFill>
                   <a:srgbClr val="1A1A1A"/>
                 </a:solidFill>
                 <a:latin typeface="Calibri"/>
               </a:rPr>
-              <a:t/>
+              <a:t>Na aula: just treino  →  depois  just serve.</a:t>
             </a:r>
           </a:p>
           <a:p>
             <a:pPr algn="l">
               <a:spcAft>
-                <a:spcPts val="300"/>
+                <a:spcPts val="400"/>
               </a:spcAft>
             </a:pPr>
             <a:r>
-              <a:rPr sz="1500" b="0">
+              <a:rPr sz="1600" b="0">
                 <a:solidFill>
                   <a:srgbClr val="1A1A1A"/>
                 </a:solidFill>
                 <a:latin typeface="Calibri"/>
               </a:rPr>
-              <a:t>2. Nota = 0,7×popularidade + 0,3×juntos</a:t>
-            </a:r>
-          </a:p>
-          <a:p>
-            <a:pPr algn="l">
-              <a:spcAft>
-                <a:spcPts val="300"/>
-              </a:spcAft>
-            </a:pPr>
-            <a:r>
-              <a:rPr sz="1500" b="0">
-                <a:solidFill>
-                  <a:srgbClr val="1A1A1A"/>
-                </a:solidFill>
-                <a:latin typeface="Calibri"/>
-              </a:rPr>
-              <a:t>   Prato ≈ 0,77 · Boneca ≈ 0,52</a:t>
-            </a:r>
-          </a:p>
-          <a:p>
-            <a:pPr algn="l">
-              <a:spcAft>
-                <a:spcPts val="300"/>
-              </a:spcAft>
-            </a:pPr>
-            <a:r>
-              <a:rPr sz="1500" b="0">
-                <a:solidFill>
-                  <a:srgbClr val="1A1A1A"/>
-                </a:solidFill>
-                <a:latin typeface="Calibri"/>
-              </a:rPr>
-              <a:t/>
-            </a:r>
-          </a:p>
-          <a:p>
-            <a:pPr algn="l">
-              <a:spcAft>
-                <a:spcPts val="300"/>
-              </a:spcAft>
-            </a:pPr>
-            <a:r>
-              <a:rPr sz="1500" b="0">
-                <a:solidFill>
-                  <a:srgbClr val="1A1A1A"/>
-                </a:solidFill>
-                <a:latin typeface="Calibri"/>
-              </a:rPr>
-              <a:t>3. Completar com os mais pedidos:</a:t>
-            </a:r>
-          </a:p>
-          <a:p>
-            <a:pPr algn="l">
-              <a:spcAft>
-                <a:spcPts val="300"/>
-              </a:spcAft>
-            </a:pPr>
-            <a:r>
-              <a:rPr sz="1500" b="0">
-                <a:solidFill>
-                  <a:srgbClr val="1A1A1A"/>
-                </a:solidFill>
-                <a:latin typeface="Calibri"/>
-              </a:rPr>
-              <a:t>   Rendeira ≈ 0,42 · Xilogravura ≈ 0,37</a:t>
-            </a:r>
-          </a:p>
-          <a:p>
-            <a:pPr algn="l">
-              <a:spcAft>
-                <a:spcPts val="300"/>
-              </a:spcAft>
-            </a:pPr>
-            <a:r>
-              <a:rPr sz="1500" b="0">
-                <a:solidFill>
-                  <a:srgbClr val="1A1A1A"/>
-                </a:solidFill>
-                <a:latin typeface="Calibri"/>
-              </a:rPr>
-              <a:t/>
-            </a:r>
-          </a:p>
-          <a:p>
-            <a:pPr algn="l">
-              <a:spcAft>
-                <a:spcPts val="300"/>
-              </a:spcAft>
-            </a:pPr>
-            <a:r>
-              <a:rPr sz="1500" b="0">
-                <a:solidFill>
-                  <a:srgbClr val="1A1A1A"/>
-                </a:solidFill>
-                <a:latin typeface="Calibri"/>
-              </a:rPr>
-              <a:t>Detalhe das contas:</a:t>
-            </a:r>
-          </a:p>
-          <a:p>
-            <a:pPr algn="l">
-              <a:spcAft>
-                <a:spcPts val="300"/>
-              </a:spcAft>
-            </a:pPr>
-            <a:r>
-              <a:rPr sz="1500" b="0">
-                <a:solidFill>
-                  <a:srgbClr val="1A1A1A"/>
-                </a:solidFill>
-                <a:latin typeface="Calibri"/>
-              </a:rPr>
-              <a:t>material/calculos-trabalhados.md</a:t>
-            </a:r>
-          </a:p>
-        </p:txBody>
-      </p:sp>
-      <p:sp>
-        <p:nvSpPr>
-          <p:cNvPr id="7" name="Rounded Rectangle 6"/>
-          <p:cNvSpPr/>
-          <p:nvPr/>
-        </p:nvSpPr>
-        <p:spPr>
-          <a:xfrm>
-            <a:off x="6400800" y="1234440"/>
-            <a:ext cx="5212080" cy="4480560"/>
-          </a:xfrm>
-          <a:prstGeom prst="roundRect">
-            <a:avLst/>
-          </a:prstGeom>
-          <a:solidFill>
-            <a:srgbClr val="1E2A2E"/>
-          </a:solidFill>
-          <a:ln>
-            <a:noFill/>
-          </a:ln>
-          <a:effectLst/>
-        </p:spPr>
-        <p:style>
-          <a:lnRef idx="1">
-            <a:schemeClr val="accent1"/>
-          </a:lnRef>
-          <a:fillRef idx="3">
-            <a:schemeClr val="accent1"/>
-          </a:fillRef>
-          <a:effectRef idx="2">
-            <a:schemeClr val="accent1"/>
-          </a:effectRef>
-          <a:fontRef idx="minor">
-            <a:schemeClr val="lt1"/>
-          </a:fontRef>
-        </p:style>
-        <p:txBody>
-          <a:bodyPr rtlCol="0" anchor="ctr"/>
-          <a:lstStyle/>
-          <a:p>
-            <a:pPr algn="ctr"/>
-          </a:p>
-        </p:txBody>
-      </p:sp>
-      <p:sp>
-        <p:nvSpPr>
-          <p:cNvPr id="8" name="TextBox 7"/>
-          <p:cNvSpPr txBox="1"/>
-          <p:nvPr/>
-        </p:nvSpPr>
-        <p:spPr>
-          <a:xfrm>
-            <a:off x="6583680" y="1417320"/>
-            <a:ext cx="4846320" cy="4114800"/>
-          </a:xfrm>
-          <a:prstGeom prst="rect">
-            <a:avLst/>
-          </a:prstGeom>
-          <a:noFill/>
-        </p:spPr>
-        <p:txBody>
-          <a:bodyPr wrap="square" lIns="50800" rIns="50800" tIns="25400" bIns="25400">
-            <a:spAutoFit/>
-          </a:bodyPr>
-          <a:lstStyle/>
-          <a:p>
-            <a:pPr algn="l">
-              <a:spcAft>
-                <a:spcPts val="500"/>
-              </a:spcAft>
-            </a:pPr>
-            <a:r>
-              <a:rPr sz="1700" b="0">
-                <a:solidFill>
-                  <a:srgbClr val="FFFFFF"/>
-                </a:solidFill>
-                <a:latin typeface="Calibri"/>
-              </a:rPr>
-              <a:t>Lista devolvida</a:t>
-            </a:r>
-          </a:p>
-          <a:p>
-            <a:pPr algn="l">
-              <a:spcAft>
-                <a:spcPts val="500"/>
-              </a:spcAft>
-            </a:pPr>
-            <a:r>
-              <a:rPr sz="1700" b="0">
-                <a:solidFill>
-                  <a:srgbClr val="FFFFFF"/>
-                </a:solidFill>
-                <a:latin typeface="Calibri"/>
-              </a:rPr>
-              <a:t/>
-            </a:r>
-          </a:p>
-          <a:p>
-            <a:pPr algn="l">
-              <a:spcAft>
-                <a:spcPts val="500"/>
-              </a:spcAft>
-            </a:pPr>
-            <a:r>
-              <a:rPr sz="1700" b="0">
-                <a:solidFill>
-                  <a:srgbClr val="FFFFFF"/>
-                </a:solidFill>
-                <a:latin typeface="Calibri"/>
-              </a:rPr>
-              <a:t>1  Prato esmaltado</a:t>
-            </a:r>
-          </a:p>
-          <a:p>
-            <a:pPr algn="l">
-              <a:spcAft>
-                <a:spcPts val="500"/>
-              </a:spcAft>
-            </a:pPr>
-            <a:r>
-              <a:rPr sz="1700" b="0">
-                <a:solidFill>
-                  <a:srgbClr val="FFFFFF"/>
-                </a:solidFill>
-                <a:latin typeface="Calibri"/>
-              </a:rPr>
-              <a:t>2  Boneca de barro</a:t>
-            </a:r>
-          </a:p>
-          <a:p>
-            <a:pPr algn="l">
-              <a:spcAft>
-                <a:spcPts val="500"/>
-              </a:spcAft>
-            </a:pPr>
-            <a:r>
-              <a:rPr sz="1700" b="0">
-                <a:solidFill>
-                  <a:srgbClr val="FFFFFF"/>
-                </a:solidFill>
-                <a:latin typeface="Calibri"/>
-              </a:rPr>
-              <a:t>3  Rendeira Alto do Moura</a:t>
-            </a:r>
-          </a:p>
-          <a:p>
-            <a:pPr algn="l">
-              <a:spcAft>
-                <a:spcPts val="500"/>
-              </a:spcAft>
-            </a:pPr>
-            <a:r>
-              <a:rPr sz="1700" b="0">
-                <a:solidFill>
-                  <a:srgbClr val="FFFFFF"/>
-                </a:solidFill>
-                <a:latin typeface="Calibri"/>
-              </a:rPr>
-              <a:t>4  Xilogravura Pilar</a:t>
-            </a:r>
-          </a:p>
-          <a:p>
-            <a:pPr algn="l">
-              <a:spcAft>
-                <a:spcPts val="500"/>
-              </a:spcAft>
-            </a:pPr>
-            <a:r>
-              <a:rPr sz="1700" b="0">
-                <a:solidFill>
-                  <a:srgbClr val="FFFFFF"/>
-                </a:solidFill>
-                <a:latin typeface="Calibri"/>
-              </a:rPr>
-              <a:t/>
-            </a:r>
-          </a:p>
-          <a:p>
-            <a:pPr algn="l">
-              <a:spcAft>
-                <a:spcPts val="500"/>
-              </a:spcAft>
-            </a:pPr>
-            <a:r>
-              <a:rPr sz="1700" b="0">
-                <a:solidFill>
-                  <a:srgbClr val="FFFFFF"/>
-                </a:solidFill>
-                <a:latin typeface="Calibri"/>
-              </a:rPr>
-              <a:t>just curl-exemplo</a:t>
-            </a:r>
-          </a:p>
-        </p:txBody>
-      </p:sp>
-      <p:sp>
-        <p:nvSpPr>
-          <p:cNvPr id="9" name="TextBox 8"/>
+              <a:t>O cliente HTTP nunca chama treino.py; só o endpoint recomendar.</a:t>
+            </a:r>
+          </a:p>
+        </p:txBody>
+      </p:sp>
+      <p:sp>
+        <p:nvSpPr>
+          <p:cNvPr id="17" name="TextBox 16"/>
           <p:cNvSpPr txBox="1"/>
           <p:nvPr/>
         </p:nvSpPr>
@@ -5573,7 +5839,7 @@
                 </a:solidFill>
                 <a:latin typeface="Calibri"/>
               </a:rPr>
-              <a:t>3 / 5</a:t>
+              <a:t>3 / 6</a:t>
             </a:r>
           </a:p>
         </p:txBody>
@@ -5611,11 +5877,378 @@
             <a:avLst/>
           </a:prstGeom>
           <a:solidFill>
+            <a:srgbClr val="F7F5F0"/>
+          </a:solidFill>
+          <a:ln>
+            <a:noFill/>
+          </a:ln>
+        </p:spPr>
+        <p:style>
+          <a:lnRef idx="1">
+            <a:schemeClr val="accent1"/>
+          </a:lnRef>
+          <a:fillRef idx="3">
+            <a:schemeClr val="accent1"/>
+          </a:fillRef>
+          <a:effectRef idx="2">
+            <a:schemeClr val="accent1"/>
+          </a:effectRef>
+          <a:fontRef idx="minor">
+            <a:schemeClr val="lt1"/>
+          </a:fontRef>
+        </p:style>
+        <p:txBody>
+          <a:bodyPr rtlCol="0" anchor="ctr"/>
+          <a:lstStyle/>
+          <a:p>
+            <a:pPr algn="ctr"/>
+          </a:p>
+        </p:txBody>
+      </p:sp>
+      <p:sp>
+        <p:nvSpPr>
+          <p:cNvPr id="3" name="TextBox 2"/>
+          <p:cNvSpPr txBox="1"/>
+          <p:nvPr/>
+        </p:nvSpPr>
+        <p:spPr>
+          <a:xfrm>
+            <a:off x="502920" y="228600"/>
+            <a:ext cx="11155680" cy="457200"/>
+          </a:xfrm>
+          <a:prstGeom prst="rect">
+            <a:avLst/>
+          </a:prstGeom>
+          <a:noFill/>
+        </p:spPr>
+        <p:txBody>
+          <a:bodyPr wrap="square" lIns="50800" rIns="50800" tIns="25400" bIns="25400">
+            <a:spAutoFit/>
+          </a:bodyPr>
+          <a:lstStyle/>
+          <a:p>
+            <a:pPr algn="l">
+              <a:spcAft>
+                <a:spcPts val="800"/>
+              </a:spcAft>
+            </a:pPr>
+            <a:r>
+              <a:rPr sz="2600" b="1">
+                <a:solidFill>
+                  <a:srgbClr val="1A1A1A"/>
+                </a:solidFill>
+                <a:latin typeface="Georgia"/>
+              </a:rPr>
+              <a:t>Exemplo: cliente abriu o Jarro de barro</a:t>
+            </a:r>
+          </a:p>
+        </p:txBody>
+      </p:sp>
+      <p:sp>
+        <p:nvSpPr>
+          <p:cNvPr id="4" name="TextBox 3"/>
+          <p:cNvSpPr txBox="1"/>
+          <p:nvPr/>
+        </p:nvSpPr>
+        <p:spPr>
+          <a:xfrm>
+            <a:off x="502920" y="731520"/>
+            <a:ext cx="11155680" cy="365760"/>
+          </a:xfrm>
+          <a:prstGeom prst="rect">
+            <a:avLst/>
+          </a:prstGeom>
+          <a:noFill/>
+        </p:spPr>
+        <p:txBody>
+          <a:bodyPr wrap="square" lIns="50800" rIns="50800" tIns="25400" bIns="25400">
+            <a:spAutoFit/>
+          </a:bodyPr>
+          <a:lstStyle/>
+          <a:p>
+            <a:pPr algn="l">
+              <a:spcAft>
+                <a:spcPts val="800"/>
+              </a:spcAft>
+            </a:pPr>
+            <a:r>
+              <a:rPr sz="1500" b="0">
+                <a:solidFill>
+                  <a:srgbClr val="4A5558"/>
+                </a:solidFill>
+                <a:latin typeface="Calibri"/>
+              </a:rPr>
+              <a:t>produto_na_pagina = p01 · técnica = cerâmica · pedimos 4 sugestões</a:t>
+            </a:r>
+          </a:p>
+        </p:txBody>
+      </p:sp>
+      <p:sp>
+        <p:nvSpPr>
+          <p:cNvPr id="5" name="Rounded Rectangle 4"/>
+          <p:cNvSpPr/>
+          <p:nvPr/>
+        </p:nvSpPr>
+        <p:spPr>
+          <a:xfrm>
+            <a:off x="457200" y="1234440"/>
+            <a:ext cx="5669280" cy="4480560"/>
+          </a:xfrm>
+          <a:prstGeom prst="roundRect">
+            <a:avLst/>
+          </a:prstGeom>
+          <a:solidFill>
+            <a:srgbClr val="E8F2F0"/>
+          </a:solidFill>
+          <a:ln w="15875">
+            <a:solidFill>
+              <a:srgbClr val="0D7A6F"/>
+            </a:solidFill>
+          </a:ln>
+          <a:effectLst/>
+        </p:spPr>
+        <p:style>
+          <a:lnRef idx="1">
+            <a:schemeClr val="accent1"/>
+          </a:lnRef>
+          <a:fillRef idx="3">
+            <a:schemeClr val="accent1"/>
+          </a:fillRef>
+          <a:effectRef idx="2">
+            <a:schemeClr val="accent1"/>
+          </a:effectRef>
+          <a:fontRef idx="minor">
+            <a:schemeClr val="lt1"/>
+          </a:fontRef>
+        </p:style>
+        <p:txBody>
+          <a:bodyPr rtlCol="0" anchor="ctr"/>
+          <a:lstStyle/>
+          <a:p>
+            <a:pPr algn="ctr"/>
+          </a:p>
+        </p:txBody>
+      </p:sp>
+      <p:sp>
+        <p:nvSpPr>
+          <p:cNvPr id="6" name="TextBox 5"/>
+          <p:cNvSpPr txBox="1"/>
+          <p:nvPr/>
+        </p:nvSpPr>
+        <p:spPr>
+          <a:xfrm>
+            <a:off x="640080" y="1371600"/>
+            <a:ext cx="5303520" cy="4206240"/>
+          </a:xfrm>
+          <a:prstGeom prst="rect">
+            <a:avLst/>
+          </a:prstGeom>
+          <a:noFill/>
+        </p:spPr>
+        <p:txBody>
+          <a:bodyPr wrap="square" lIns="50800" rIns="50800" tIns="25400" bIns="25400">
+            <a:spAutoFit/>
+          </a:bodyPr>
+          <a:lstStyle/>
+          <a:p>
+            <a:pPr algn="l">
+              <a:spcAft>
+                <a:spcPts val="300"/>
+              </a:spcAft>
+            </a:pPr>
+            <a:r>
+              <a:rPr sz="1500" b="0">
+                <a:solidFill>
+                  <a:srgbClr val="1A1A1A"/>
+                </a:solidFill>
+                <a:latin typeface="Calibri"/>
+              </a:rPr>
+              <a:t>1. Outros de cerâmica: Prato, Boneca</a:t>
+            </a:r>
+          </a:p>
+          <a:p>
+            <a:pPr algn="l">
+              <a:spcAft>
+                <a:spcPts val="300"/>
+              </a:spcAft>
+            </a:pPr>
+            <a:r>
+              <a:rPr sz="1500" b="0">
+                <a:solidFill>
+                  <a:srgbClr val="1A1A1A"/>
+                </a:solidFill>
+                <a:latin typeface="Calibri"/>
+              </a:rPr>
+              <a:t>   (só 2 — ainda faltam vagas)</a:t>
+            </a:r>
+          </a:p>
+          <a:p>
+            <a:pPr algn="l">
+              <a:spcAft>
+                <a:spcPts val="300"/>
+              </a:spcAft>
+            </a:pPr>
+            <a:r>
+              <a:rPr sz="1500" b="0">
+                <a:solidFill>
+                  <a:srgbClr val="1A1A1A"/>
+                </a:solidFill>
+                <a:latin typeface="Calibri"/>
+              </a:rPr>
+              <a:t/>
+            </a:r>
+          </a:p>
+          <a:p>
+            <a:pPr algn="l">
+              <a:spcAft>
+                <a:spcPts val="300"/>
+              </a:spcAft>
+            </a:pPr>
+            <a:r>
+              <a:rPr sz="1500" b="0">
+                <a:solidFill>
+                  <a:srgbClr val="1A1A1A"/>
+                </a:solidFill>
+                <a:latin typeface="Calibri"/>
+              </a:rPr>
+              <a:t>2. Nota = 0,7×popularidade + 0,3×juntos</a:t>
+            </a:r>
+          </a:p>
+          <a:p>
+            <a:pPr algn="l">
+              <a:spcAft>
+                <a:spcPts val="300"/>
+              </a:spcAft>
+            </a:pPr>
+            <a:r>
+              <a:rPr sz="1500" b="0">
+                <a:solidFill>
+                  <a:srgbClr val="1A1A1A"/>
+                </a:solidFill>
+                <a:latin typeface="Calibri"/>
+              </a:rPr>
+              <a:t>   Prato ≈ 0,77 · Boneca ≈ 0,52</a:t>
+            </a:r>
+          </a:p>
+          <a:p>
+            <a:pPr algn="l">
+              <a:spcAft>
+                <a:spcPts val="300"/>
+              </a:spcAft>
+            </a:pPr>
+            <a:r>
+              <a:rPr sz="1500" b="0">
+                <a:solidFill>
+                  <a:srgbClr val="1A1A1A"/>
+                </a:solidFill>
+                <a:latin typeface="Calibri"/>
+              </a:rPr>
+              <a:t/>
+            </a:r>
+          </a:p>
+          <a:p>
+            <a:pPr algn="l">
+              <a:spcAft>
+                <a:spcPts val="300"/>
+              </a:spcAft>
+            </a:pPr>
+            <a:r>
+              <a:rPr sz="1500" b="0">
+                <a:solidFill>
+                  <a:srgbClr val="1A1A1A"/>
+                </a:solidFill>
+                <a:latin typeface="Calibri"/>
+              </a:rPr>
+              <a:t>3. Completar com os mais pedidos:</a:t>
+            </a:r>
+          </a:p>
+          <a:p>
+            <a:pPr algn="l">
+              <a:spcAft>
+                <a:spcPts val="300"/>
+              </a:spcAft>
+            </a:pPr>
+            <a:r>
+              <a:rPr sz="1500" b="0">
+                <a:solidFill>
+                  <a:srgbClr val="1A1A1A"/>
+                </a:solidFill>
+                <a:latin typeface="Calibri"/>
+              </a:rPr>
+              <a:t>   Rendeira ≈ 0,42 · Xilogravura ≈ 0,37</a:t>
+            </a:r>
+          </a:p>
+          <a:p>
+            <a:pPr algn="l">
+              <a:spcAft>
+                <a:spcPts val="300"/>
+              </a:spcAft>
+            </a:pPr>
+            <a:r>
+              <a:rPr sz="1500" b="0">
+                <a:solidFill>
+                  <a:srgbClr val="1A1A1A"/>
+                </a:solidFill>
+                <a:latin typeface="Calibri"/>
+              </a:rPr>
+              <a:t/>
+            </a:r>
+          </a:p>
+          <a:p>
+            <a:pPr algn="l">
+              <a:spcAft>
+                <a:spcPts val="300"/>
+              </a:spcAft>
+            </a:pPr>
+            <a:r>
+              <a:rPr sz="1500" b="0">
+                <a:solidFill>
+                  <a:srgbClr val="1A1A1A"/>
+                </a:solidFill>
+                <a:latin typeface="Calibri"/>
+              </a:rPr>
+              <a:t>Detalhe das contas:</a:t>
+            </a:r>
+          </a:p>
+          <a:p>
+            <a:pPr algn="l">
+              <a:spcAft>
+                <a:spcPts val="300"/>
+              </a:spcAft>
+            </a:pPr>
+            <a:r>
+              <a:rPr sz="1500" b="0">
+                <a:solidFill>
+                  <a:srgbClr val="1A1A1A"/>
+                </a:solidFill>
+                <a:latin typeface="Calibri"/>
+              </a:rPr>
+              <a:t>material/calculos-trabalhados.md</a:t>
+            </a:r>
+          </a:p>
+        </p:txBody>
+      </p:sp>
+      <p:sp>
+        <p:nvSpPr>
+          <p:cNvPr id="7" name="Rounded Rectangle 6"/>
+          <p:cNvSpPr/>
+          <p:nvPr/>
+        </p:nvSpPr>
+        <p:spPr>
+          <a:xfrm>
+            <a:off x="6400800" y="1234440"/>
+            <a:ext cx="5212080" cy="4480560"/>
+          </a:xfrm>
+          <a:prstGeom prst="roundRect">
+            <a:avLst/>
+          </a:prstGeom>
+          <a:solidFill>
             <a:srgbClr val="1E2A2E"/>
           </a:solidFill>
           <a:ln>
             <a:noFill/>
           </a:ln>
+          <a:effectLst/>
         </p:spPr>
         <p:style>
           <a:lnRef idx="1">
@@ -5641,14 +6274,165 @@
       </p:sp>
       <p:sp>
         <p:nvSpPr>
-          <p:cNvPr id="3" name="TextBox 2"/>
+          <p:cNvPr id="8" name="TextBox 7"/>
           <p:cNvSpPr txBox="1"/>
           <p:nvPr/>
         </p:nvSpPr>
         <p:spPr>
           <a:xfrm>
-            <a:off x="548640" y="274320"/>
-            <a:ext cx="10972800" cy="457200"/>
+            <a:off x="6583680" y="1417320"/>
+            <a:ext cx="4846320" cy="4114800"/>
+          </a:xfrm>
+          <a:prstGeom prst="rect">
+            <a:avLst/>
+          </a:prstGeom>
+          <a:noFill/>
+        </p:spPr>
+        <p:txBody>
+          <a:bodyPr wrap="square" lIns="50800" rIns="50800" tIns="25400" bIns="25400">
+            <a:spAutoFit/>
+          </a:bodyPr>
+          <a:lstStyle/>
+          <a:p>
+            <a:pPr algn="l">
+              <a:spcAft>
+                <a:spcPts val="500"/>
+              </a:spcAft>
+            </a:pPr>
+            <a:r>
+              <a:rPr sz="1700" b="0">
+                <a:solidFill>
+                  <a:srgbClr val="FFFFFF"/>
+                </a:solidFill>
+                <a:latin typeface="Calibri"/>
+              </a:rPr>
+              <a:t>Lista devolvida</a:t>
+            </a:r>
+          </a:p>
+          <a:p>
+            <a:pPr algn="l">
+              <a:spcAft>
+                <a:spcPts val="500"/>
+              </a:spcAft>
+            </a:pPr>
+            <a:r>
+              <a:rPr sz="1700" b="0">
+                <a:solidFill>
+                  <a:srgbClr val="FFFFFF"/>
+                </a:solidFill>
+                <a:latin typeface="Calibri"/>
+              </a:rPr>
+              <a:t/>
+            </a:r>
+          </a:p>
+          <a:p>
+            <a:pPr algn="l">
+              <a:spcAft>
+                <a:spcPts val="500"/>
+              </a:spcAft>
+            </a:pPr>
+            <a:r>
+              <a:rPr sz="1700" b="0">
+                <a:solidFill>
+                  <a:srgbClr val="FFFFFF"/>
+                </a:solidFill>
+                <a:latin typeface="Calibri"/>
+              </a:rPr>
+              <a:t>1  Prato esmaltado</a:t>
+            </a:r>
+          </a:p>
+          <a:p>
+            <a:pPr algn="l">
+              <a:spcAft>
+                <a:spcPts val="500"/>
+              </a:spcAft>
+            </a:pPr>
+            <a:r>
+              <a:rPr sz="1700" b="0">
+                <a:solidFill>
+                  <a:srgbClr val="FFFFFF"/>
+                </a:solidFill>
+                <a:latin typeface="Calibri"/>
+              </a:rPr>
+              <a:t>2  Boneca de barro</a:t>
+            </a:r>
+          </a:p>
+          <a:p>
+            <a:pPr algn="l">
+              <a:spcAft>
+                <a:spcPts val="500"/>
+              </a:spcAft>
+            </a:pPr>
+            <a:r>
+              <a:rPr sz="1700" b="0">
+                <a:solidFill>
+                  <a:srgbClr val="FFFFFF"/>
+                </a:solidFill>
+                <a:latin typeface="Calibri"/>
+              </a:rPr>
+              <a:t>3  Rendeira Alto do Moura</a:t>
+            </a:r>
+          </a:p>
+          <a:p>
+            <a:pPr algn="l">
+              <a:spcAft>
+                <a:spcPts val="500"/>
+              </a:spcAft>
+            </a:pPr>
+            <a:r>
+              <a:rPr sz="1700" b="0">
+                <a:solidFill>
+                  <a:srgbClr val="FFFFFF"/>
+                </a:solidFill>
+                <a:latin typeface="Calibri"/>
+              </a:rPr>
+              <a:t>4  Xilogravura Pilar</a:t>
+            </a:r>
+          </a:p>
+          <a:p>
+            <a:pPr algn="l">
+              <a:spcAft>
+                <a:spcPts val="500"/>
+              </a:spcAft>
+            </a:pPr>
+            <a:r>
+              <a:rPr sz="1700" b="0">
+                <a:solidFill>
+                  <a:srgbClr val="FFFFFF"/>
+                </a:solidFill>
+                <a:latin typeface="Calibri"/>
+              </a:rPr>
+              <a:t/>
+            </a:r>
+          </a:p>
+          <a:p>
+            <a:pPr algn="l">
+              <a:spcAft>
+                <a:spcPts val="500"/>
+              </a:spcAft>
+            </a:pPr>
+            <a:r>
+              <a:rPr sz="1700" b="0">
+                <a:solidFill>
+                  <a:srgbClr val="FFFFFF"/>
+                </a:solidFill>
+                <a:latin typeface="Calibri"/>
+              </a:rPr>
+              <a:t>just curl-exemplo</a:t>
+            </a:r>
+          </a:p>
+        </p:txBody>
+      </p:sp>
+      <p:sp>
+        <p:nvSpPr>
+          <p:cNvPr id="9" name="TextBox 8"/>
+          <p:cNvSpPr txBox="1"/>
+          <p:nvPr/>
+        </p:nvSpPr>
+        <p:spPr>
+          <a:xfrm>
+            <a:off x="502920" y="6126480"/>
+            <a:ext cx="10972800" cy="320040"/>
           </a:xfrm>
           <a:prstGeom prst="rect">
             <a:avLst/>
@@ -5667,263 +6451,13 @@
               </a:spcAft>
             </a:pPr>
             <a:r>
-              <a:rPr sz="2800" b="1">
-                <a:solidFill>
-                  <a:srgbClr val="FFFFFF"/>
-                </a:solidFill>
-                <a:latin typeface="Georgia"/>
-              </a:rPr>
-              <a:t>Mesmos passos no código</a:t>
-            </a:r>
-          </a:p>
-        </p:txBody>
-      </p:sp>
-      <p:sp>
-        <p:nvSpPr>
-          <p:cNvPr id="4" name="Rounded Rectangle 3"/>
-          <p:cNvSpPr/>
-          <p:nvPr/>
-        </p:nvSpPr>
-        <p:spPr>
-          <a:xfrm>
-            <a:off x="548640" y="914400"/>
-            <a:ext cx="11064240" cy="4754880"/>
-          </a:xfrm>
-          <a:prstGeom prst="roundRect">
-            <a:avLst/>
-          </a:prstGeom>
-          <a:solidFill>
-            <a:srgbClr val="243236"/>
-          </a:solidFill>
-          <a:ln>
-            <a:noFill/>
-          </a:ln>
-          <a:effectLst/>
-        </p:spPr>
-        <p:style>
-          <a:lnRef idx="1">
-            <a:schemeClr val="accent1"/>
-          </a:lnRef>
-          <a:fillRef idx="3">
-            <a:schemeClr val="accent1"/>
-          </a:fillRef>
-          <a:effectRef idx="2">
-            <a:schemeClr val="accent1"/>
-          </a:effectRef>
-          <a:fontRef idx="minor">
-            <a:schemeClr val="lt1"/>
-          </a:fontRef>
-        </p:style>
-        <p:txBody>
-          <a:bodyPr rtlCol="0" anchor="ctr"/>
-          <a:lstStyle/>
-          <a:p>
-            <a:pPr algn="ctr"/>
-          </a:p>
-        </p:txBody>
-      </p:sp>
-      <p:sp>
-        <p:nvSpPr>
-          <p:cNvPr id="5" name="TextBox 4"/>
-          <p:cNvSpPr txBox="1"/>
-          <p:nvPr/>
-        </p:nvSpPr>
-        <p:spPr>
-          <a:xfrm>
-            <a:off x="777240" y="1097280"/>
-            <a:ext cx="10607040" cy="4389120"/>
-          </a:xfrm>
-          <a:prstGeom prst="rect">
-            <a:avLst/>
-          </a:prstGeom>
-          <a:noFill/>
-        </p:spPr>
-        <p:txBody>
-          <a:bodyPr wrap="square" lIns="50800" rIns="50800" tIns="25400" bIns="25400">
-            <a:spAutoFit/>
-          </a:bodyPr>
-          <a:lstStyle/>
-          <a:p>
-            <a:pPr algn="l">
-              <a:spcAft>
-                <a:spcPts val="500"/>
-              </a:spcAft>
-            </a:pPr>
-            <a:r>
-              <a:rPr sz="1700" b="0">
-                <a:solidFill>
-                  <a:srgbClr val="B8E0D8"/>
-                </a:solidFill>
-                <a:latin typeface="Consolas"/>
-              </a:rPr>
-              <a:t># service.py — função recomendar</a:t>
-            </a:r>
-          </a:p>
-          <a:p>
-            <a:pPr algn="l">
-              <a:spcAft>
-                <a:spcPts val="500"/>
-              </a:spcAft>
-            </a:pPr>
-            <a:r>
-              <a:rPr sz="1700" b="0">
-                <a:solidFill>
-                  <a:srgbClr val="B8E0D8"/>
-                </a:solidFill>
-                <a:latin typeface="Consolas"/>
-              </a:rPr>
-              <a:t/>
-            </a:r>
-          </a:p>
-          <a:p>
-            <a:pPr algn="l">
-              <a:spcAft>
-                <a:spcPts val="500"/>
-              </a:spcAft>
-            </a:pPr>
-            <a:r>
-              <a:rPr sz="1700" b="0">
-                <a:solidFill>
-                  <a:srgbClr val="B8E0D8"/>
-                </a:solidFill>
-                <a:latin typeface="Consolas"/>
-              </a:rPr>
-              <a:t># passo 1  candidatos = mesma técnica do produto_na_pagina</a:t>
-            </a:r>
-          </a:p>
-          <a:p>
-            <a:pPr algn="l">
-              <a:spcAft>
-                <a:spcPts val="500"/>
-              </a:spcAft>
-            </a:pPr>
-            <a:r>
-              <a:rPr sz="1700" b="0">
-                <a:solidFill>
-                  <a:srgbClr val="B8E0D8"/>
-                </a:solidFill>
-                <a:latin typeface="Consolas"/>
-              </a:rPr>
-              <a:t># passo 2  ordenar por pedidos (+ “juntos” nas cestas)</a:t>
-            </a:r>
-          </a:p>
-          <a:p>
-            <a:pPr algn="l">
-              <a:spcAft>
-                <a:spcPts val="500"/>
-              </a:spcAft>
-            </a:pPr>
-            <a:r>
-              <a:rPr sz="1700" b="0">
-                <a:solidFill>
-                  <a:srgbClr val="B8E0D8"/>
-                </a:solidFill>
-                <a:latin typeface="Consolas"/>
-              </a:rPr>
-              <a:t># passo 3  se ainda faltar vaga → pegar os mais pedidos</a:t>
-            </a:r>
-          </a:p>
-          <a:p>
-            <a:pPr algn="l">
-              <a:spcAft>
-                <a:spcPts val="500"/>
-              </a:spcAft>
-            </a:pPr>
-            <a:r>
-              <a:rPr sz="1700" b="0">
-                <a:solidFill>
-                  <a:srgbClr val="B8E0D8"/>
-                </a:solidFill>
-                <a:latin typeface="Consolas"/>
-              </a:rPr>
-              <a:t># passo 4  montar items[] com nome, score, reason, rank</a:t>
-            </a:r>
-          </a:p>
-          <a:p>
-            <a:pPr algn="l">
-              <a:spcAft>
-                <a:spcPts val="500"/>
-              </a:spcAft>
-            </a:pPr>
-            <a:r>
-              <a:rPr sz="1700" b="0">
-                <a:solidFill>
-                  <a:srgbClr val="B8E0D8"/>
-                </a:solidFill>
-                <a:latin typeface="Consolas"/>
-              </a:rPr>
-              <a:t/>
-            </a:r>
-          </a:p>
-          <a:p>
-            <a:pPr algn="l">
-              <a:spcAft>
-                <a:spcPts val="500"/>
-              </a:spcAft>
-            </a:pPr>
-            <a:r>
-              <a:rPr sz="1700" b="0">
-                <a:solidFill>
-                  <a:srgbClr val="B8E0D8"/>
-                </a:solidFill>
-                <a:latin typeface="Consolas"/>
-              </a:rPr>
-              <a:t># treino.py — roda antes, uma vez</a:t>
-            </a:r>
-          </a:p>
-          <a:p>
-            <a:pPr algn="l">
-              <a:spcAft>
-                <a:spcPts val="500"/>
-              </a:spcAft>
-            </a:pPr>
-            <a:r>
-              <a:rPr sz="1700" b="0">
-                <a:solidFill>
-                  <a:srgbClr val="B8E0D8"/>
-                </a:solidFill>
-                <a:latin typeface="Consolas"/>
-              </a:rPr>
-              <a:t># lê catalogo.json  →  grava popularidade e similaridade</a:t>
-            </a:r>
-          </a:p>
-        </p:txBody>
-      </p:sp>
-      <p:sp>
-        <p:nvSpPr>
-          <p:cNvPr id="6" name="TextBox 5"/>
-          <p:cNvSpPr txBox="1"/>
-          <p:nvPr/>
-        </p:nvSpPr>
-        <p:spPr>
-          <a:xfrm>
-            <a:off x="548640" y="6126480"/>
-            <a:ext cx="10972800" cy="320040"/>
-          </a:xfrm>
-          <a:prstGeom prst="rect">
-            <a:avLst/>
-          </a:prstGeom>
-          <a:noFill/>
-        </p:spPr>
-        <p:txBody>
-          <a:bodyPr wrap="square" lIns="50800" rIns="50800" tIns="25400" bIns="25400">
-            <a:spAutoFit/>
-          </a:bodyPr>
-          <a:lstStyle/>
-          <a:p>
-            <a:pPr algn="l">
-              <a:spcAft>
-                <a:spcPts val="800"/>
-              </a:spcAft>
-            </a:pPr>
-            <a:r>
               <a:rPr sz="1200" b="0">
                 <a:solidFill>
                   <a:srgbClr val="4A5558"/>
                 </a:solidFill>
                 <a:latin typeface="Calibri"/>
               </a:rPr>
-              <a:t>4 / 5</a:t>
+              <a:t>4 / 6</a:t>
             </a:r>
           </a:p>
         </p:txBody>
@@ -5961,6 +6495,356 @@
             <a:avLst/>
           </a:prstGeom>
           <a:solidFill>
+            <a:srgbClr val="1E2A2E"/>
+          </a:solidFill>
+          <a:ln>
+            <a:noFill/>
+          </a:ln>
+        </p:spPr>
+        <p:style>
+          <a:lnRef idx="1">
+            <a:schemeClr val="accent1"/>
+          </a:lnRef>
+          <a:fillRef idx="3">
+            <a:schemeClr val="accent1"/>
+          </a:fillRef>
+          <a:effectRef idx="2">
+            <a:schemeClr val="accent1"/>
+          </a:effectRef>
+          <a:fontRef idx="minor">
+            <a:schemeClr val="lt1"/>
+          </a:fontRef>
+        </p:style>
+        <p:txBody>
+          <a:bodyPr rtlCol="0" anchor="ctr"/>
+          <a:lstStyle/>
+          <a:p>
+            <a:pPr algn="ctr"/>
+          </a:p>
+        </p:txBody>
+      </p:sp>
+      <p:sp>
+        <p:nvSpPr>
+          <p:cNvPr id="3" name="TextBox 2"/>
+          <p:cNvSpPr txBox="1"/>
+          <p:nvPr/>
+        </p:nvSpPr>
+        <p:spPr>
+          <a:xfrm>
+            <a:off x="548640" y="274320"/>
+            <a:ext cx="10972800" cy="457200"/>
+          </a:xfrm>
+          <a:prstGeom prst="rect">
+            <a:avLst/>
+          </a:prstGeom>
+          <a:noFill/>
+        </p:spPr>
+        <p:txBody>
+          <a:bodyPr wrap="square" lIns="50800" rIns="50800" tIns="25400" bIns="25400">
+            <a:spAutoFit/>
+          </a:bodyPr>
+          <a:lstStyle/>
+          <a:p>
+            <a:pPr algn="l">
+              <a:spcAft>
+                <a:spcPts val="800"/>
+              </a:spcAft>
+            </a:pPr>
+            <a:r>
+              <a:rPr sz="2800" b="1">
+                <a:solidFill>
+                  <a:srgbClr val="FFFFFF"/>
+                </a:solidFill>
+                <a:latin typeface="Georgia"/>
+              </a:rPr>
+              <a:t>Mesmos passos no código</a:t>
+            </a:r>
+          </a:p>
+        </p:txBody>
+      </p:sp>
+      <p:sp>
+        <p:nvSpPr>
+          <p:cNvPr id="4" name="Rounded Rectangle 3"/>
+          <p:cNvSpPr/>
+          <p:nvPr/>
+        </p:nvSpPr>
+        <p:spPr>
+          <a:xfrm>
+            <a:off x="548640" y="914400"/>
+            <a:ext cx="11064240" cy="4754880"/>
+          </a:xfrm>
+          <a:prstGeom prst="roundRect">
+            <a:avLst/>
+          </a:prstGeom>
+          <a:solidFill>
+            <a:srgbClr val="243236"/>
+          </a:solidFill>
+          <a:ln>
+            <a:noFill/>
+          </a:ln>
+          <a:effectLst/>
+        </p:spPr>
+        <p:style>
+          <a:lnRef idx="1">
+            <a:schemeClr val="accent1"/>
+          </a:lnRef>
+          <a:fillRef idx="3">
+            <a:schemeClr val="accent1"/>
+          </a:fillRef>
+          <a:effectRef idx="2">
+            <a:schemeClr val="accent1"/>
+          </a:effectRef>
+          <a:fontRef idx="minor">
+            <a:schemeClr val="lt1"/>
+          </a:fontRef>
+        </p:style>
+        <p:txBody>
+          <a:bodyPr rtlCol="0" anchor="ctr"/>
+          <a:lstStyle/>
+          <a:p>
+            <a:pPr algn="ctr"/>
+          </a:p>
+        </p:txBody>
+      </p:sp>
+      <p:sp>
+        <p:nvSpPr>
+          <p:cNvPr id="5" name="TextBox 4"/>
+          <p:cNvSpPr txBox="1"/>
+          <p:nvPr/>
+        </p:nvSpPr>
+        <p:spPr>
+          <a:xfrm>
+            <a:off x="777240" y="1097280"/>
+            <a:ext cx="10607040" cy="4389120"/>
+          </a:xfrm>
+          <a:prstGeom prst="rect">
+            <a:avLst/>
+          </a:prstGeom>
+          <a:noFill/>
+        </p:spPr>
+        <p:txBody>
+          <a:bodyPr wrap="square" lIns="50800" rIns="50800" tIns="25400" bIns="25400">
+            <a:spAutoFit/>
+          </a:bodyPr>
+          <a:lstStyle/>
+          <a:p>
+            <a:pPr algn="l">
+              <a:spcAft>
+                <a:spcPts val="500"/>
+              </a:spcAft>
+            </a:pPr>
+            <a:r>
+              <a:rPr sz="1700" b="0">
+                <a:solidFill>
+                  <a:srgbClr val="B8E0D8"/>
+                </a:solidFill>
+                <a:latin typeface="Consolas"/>
+              </a:rPr>
+              <a:t># service.py — função recomendar</a:t>
+            </a:r>
+          </a:p>
+          <a:p>
+            <a:pPr algn="l">
+              <a:spcAft>
+                <a:spcPts val="500"/>
+              </a:spcAft>
+            </a:pPr>
+            <a:r>
+              <a:rPr sz="1700" b="0">
+                <a:solidFill>
+                  <a:srgbClr val="B8E0D8"/>
+                </a:solidFill>
+                <a:latin typeface="Consolas"/>
+              </a:rPr>
+              <a:t/>
+            </a:r>
+          </a:p>
+          <a:p>
+            <a:pPr algn="l">
+              <a:spcAft>
+                <a:spcPts val="500"/>
+              </a:spcAft>
+            </a:pPr>
+            <a:r>
+              <a:rPr sz="1700" b="0">
+                <a:solidFill>
+                  <a:srgbClr val="B8E0D8"/>
+                </a:solidFill>
+                <a:latin typeface="Consolas"/>
+              </a:rPr>
+              <a:t># passo 1  candidatos = mesma técnica do produto_na_pagina</a:t>
+            </a:r>
+          </a:p>
+          <a:p>
+            <a:pPr algn="l">
+              <a:spcAft>
+                <a:spcPts val="500"/>
+              </a:spcAft>
+            </a:pPr>
+            <a:r>
+              <a:rPr sz="1700" b="0">
+                <a:solidFill>
+                  <a:srgbClr val="B8E0D8"/>
+                </a:solidFill>
+                <a:latin typeface="Consolas"/>
+              </a:rPr>
+              <a:t># passo 2  ordenar por pedidos (+ “juntos” nas cestas)</a:t>
+            </a:r>
+          </a:p>
+          <a:p>
+            <a:pPr algn="l">
+              <a:spcAft>
+                <a:spcPts val="500"/>
+              </a:spcAft>
+            </a:pPr>
+            <a:r>
+              <a:rPr sz="1700" b="0">
+                <a:solidFill>
+                  <a:srgbClr val="B8E0D8"/>
+                </a:solidFill>
+                <a:latin typeface="Consolas"/>
+              </a:rPr>
+              <a:t># passo 3  se ainda faltar vaga → pegar os mais pedidos</a:t>
+            </a:r>
+          </a:p>
+          <a:p>
+            <a:pPr algn="l">
+              <a:spcAft>
+                <a:spcPts val="500"/>
+              </a:spcAft>
+            </a:pPr>
+            <a:r>
+              <a:rPr sz="1700" b="0">
+                <a:solidFill>
+                  <a:srgbClr val="B8E0D8"/>
+                </a:solidFill>
+                <a:latin typeface="Consolas"/>
+              </a:rPr>
+              <a:t># passo 4  montar items[] com nome, score, reason, rank</a:t>
+            </a:r>
+          </a:p>
+          <a:p>
+            <a:pPr algn="l">
+              <a:spcAft>
+                <a:spcPts val="500"/>
+              </a:spcAft>
+            </a:pPr>
+            <a:r>
+              <a:rPr sz="1700" b="0">
+                <a:solidFill>
+                  <a:srgbClr val="B8E0D8"/>
+                </a:solidFill>
+                <a:latin typeface="Consolas"/>
+              </a:rPr>
+              <a:t/>
+            </a:r>
+          </a:p>
+          <a:p>
+            <a:pPr algn="l">
+              <a:spcAft>
+                <a:spcPts val="500"/>
+              </a:spcAft>
+            </a:pPr>
+            <a:r>
+              <a:rPr sz="1700" b="0">
+                <a:solidFill>
+                  <a:srgbClr val="B8E0D8"/>
+                </a:solidFill>
+                <a:latin typeface="Consolas"/>
+              </a:rPr>
+              <a:t># treino.py — roda antes, uma vez</a:t>
+            </a:r>
+          </a:p>
+          <a:p>
+            <a:pPr algn="l">
+              <a:spcAft>
+                <a:spcPts val="500"/>
+              </a:spcAft>
+            </a:pPr>
+            <a:r>
+              <a:rPr sz="1700" b="0">
+                <a:solidFill>
+                  <a:srgbClr val="B8E0D8"/>
+                </a:solidFill>
+                <a:latin typeface="Consolas"/>
+              </a:rPr>
+              <a:t># lê catalogo.json  →  grava popularidade e similaridade</a:t>
+            </a:r>
+          </a:p>
+        </p:txBody>
+      </p:sp>
+      <p:sp>
+        <p:nvSpPr>
+          <p:cNvPr id="6" name="TextBox 5"/>
+          <p:cNvSpPr txBox="1"/>
+          <p:nvPr/>
+        </p:nvSpPr>
+        <p:spPr>
+          <a:xfrm>
+            <a:off x="548640" y="6126480"/>
+            <a:ext cx="10972800" cy="320040"/>
+          </a:xfrm>
+          <a:prstGeom prst="rect">
+            <a:avLst/>
+          </a:prstGeom>
+          <a:noFill/>
+        </p:spPr>
+        <p:txBody>
+          <a:bodyPr wrap="square" lIns="50800" rIns="50800" tIns="25400" bIns="25400">
+            <a:spAutoFit/>
+          </a:bodyPr>
+          <a:lstStyle/>
+          <a:p>
+            <a:pPr algn="l">
+              <a:spcAft>
+                <a:spcPts val="800"/>
+              </a:spcAft>
+            </a:pPr>
+            <a:r>
+              <a:rPr sz="1200" b="0">
+                <a:solidFill>
+                  <a:srgbClr val="4A5558"/>
+                </a:solidFill>
+                <a:latin typeface="Calibri"/>
+              </a:rPr>
+              <a:t>5 / 6</a:t>
+            </a:r>
+          </a:p>
+        </p:txBody>
+      </p:sp>
+    </p:spTree>
+  </p:cSld>
+  <p:clrMapOvr>
+    <a:masterClrMapping/>
+  </p:clrMapOvr>
+</p:sld>
+</file>
+
+<file path=ppt/slides/slide6.xml><?xml version="1.0" encoding="utf-8"?>
+<p:sld xmlns:a="http://schemas.openxmlformats.org/drawingml/2006/main" xmlns:p="http://schemas.openxmlformats.org/presentationml/2006/main" xmlns:r="http://schemas.openxmlformats.org/officeDocument/2006/relationships">
+  <p:cSld>
+    <p:spTree>
+      <p:nvGrpSpPr>
+        <p:cNvPr id="1" name=""/>
+        <p:cNvGrpSpPr/>
+        <p:nvPr/>
+      </p:nvGrpSpPr>
+      <p:grpSpPr/>
+      <p:sp>
+        <p:nvSpPr>
+          <p:cNvPr id="2" name="Rectangle 1"/>
+          <p:cNvSpPr/>
+          <p:nvPr/>
+        </p:nvSpPr>
+        <p:spPr>
+          <a:xfrm>
+            <a:off x="0" y="0"/>
+            <a:ext cx="12191695" cy="6858000"/>
+          </a:xfrm>
+          <a:prstGeom prst="rect">
+            <a:avLst/>
+          </a:prstGeom>
+          <a:solidFill>
             <a:srgbClr val="F7F5F0"/>
           </a:solidFill>
           <a:ln>
@@ -6450,7 +7334,7 @@
                 </a:solidFill>
                 <a:latin typeface="Calibri"/>
               </a:rPr>
-              <a:t>5 / 5</a:t>
+              <a:t>6 / 6</a:t>
             </a:r>
           </a:p>
         </p:txBody>

</xml_diff>

<commit_message>
refactor: alinhar nomes pop/cooc e corrigir LaTeX no GitHub
<p>Renomeia no código e na documentação popularidade_norm→pop,
similaridade→cooc e pedidos_brutos, com diagramas Mermaid e o mapa
Data Science→Microsoft Learn. Troca delimitadores \( \) / \[ \] por
$…$ e blocos ```math, que o MathJax do GitHub realmente renderiza.</p>

Co-authored-by: Cursor <cursoragent@cursor.com>
</commit_message>
<xml_diff>
--- a/slides/recomendador-bentoml.pptx
+++ b/slides/recomendador-bentoml.pptx
@@ -5768,7 +5768,7 @@
                 </a:solidFill>
                 <a:latin typeface="Calibri"/>
               </a:rPr>
-              <a:t>Saída do treino: arquivo no model store (popularidade, similaridade, nomes).</a:t>
+              <a:t>Saída do treino: arquivo no model store (pedidos_brutos, pop, cooc, nomes).</a:t>
             </a:r>
           </a:p>
           <a:p>
@@ -6768,7 +6768,7 @@
                 </a:solidFill>
                 <a:latin typeface="Consolas"/>
               </a:rPr>
-              <a:t># lê catalogo.json  →  grava popularidade e similaridade</a:t>
+              <a:t># lê catalogo.json  →  grava pedidos_brutos, pop e cooc</a:t>
             </a:r>
           </a:p>
         </p:txBody>

</xml_diff>

<commit_message>
fix: limpar notas internas e corrigir MathJax no README
<p>Remove jargão de curso (AV1, EARS, Origem/Fiscalize), alinha a
ordenação ao score documentado, renomeia o pacote para
recomendador-bentoml e troca delimitadores LaTeX: blocos $$ na coluna
zero e $`…`$ no inline — o ```math indentado no GitHub virava
&lt;pre lang=math&gt; em vez de MathJax. Inclui a pasta
variante-demografica.</p>

Co-authored-by: Cursor <cursoragent@cursor.com>
</commit_message>
<xml_diff>
--- a/slides/recomendador-bentoml.pptx
+++ b/slides/recomendador-bentoml.pptx
@@ -7263,7 +7263,7 @@
                 </a:solidFill>
                 <a:latin typeface="Calibri"/>
               </a:rPr>
-              <a:t>Depois: (1) ligar à vitrine do marketplace · (2) estudar fundamentos</a:t>
+              <a:t>O contrato da API (POST /recomendar) pode permanecer o mesmo se, mais</a:t>
             </a:r>
           </a:p>
           <a:p>
@@ -7279,23 +7279,7 @@
                 </a:solidFill>
                 <a:latin typeface="Calibri"/>
               </a:rPr>
-              <a:t>de aprendizado de máquina (Microsoft Learn, pt-BR) para trocar a regra</a:t>
-            </a:r>
-          </a:p>
-          <a:p>
-            <a:pPr algn="l">
-              <a:spcAft>
-                <a:spcPts val="300"/>
-              </a:spcAft>
-            </a:pPr>
-            <a:r>
-              <a:rPr sz="1600" b="0">
-                <a:solidFill>
-                  <a:srgbClr val="1A1A1A"/>
-                </a:solidFill>
-                <a:latin typeface="Calibri"/>
-              </a:rPr>
-              <a:t>por um modelo treinado — sem mudar o contrato da API.</a:t>
+              <a:t>tarde, a regra for trocada por um modelo treinado.</a:t>
             </a:r>
           </a:p>
         </p:txBody>

</xml_diff>